<commit_message>
Update illegal exit diagram scenarios Fixes #1
</commit_message>
<xml_diff>
--- a/hr-notes/powerpoint/hr-notes.pptx
+++ b/hr-notes/powerpoint/hr-notes.pptx
@@ -7387,7 +7387,7 @@
         <p:spPr>
           <a:xfrm>
             <a:off x="12436074" y="6348263"/>
-            <a:ext cx="5588001" cy="3404886"/>
+            <a:ext cx="5588001" cy="3221292"/>
           </a:xfrm>
           <a:prstGeom prst="rect">
             <a:avLst/>
@@ -7639,27 +7639,6 @@
             </a:pPr>
             <a:r>
               <a:t>“Lead is lost.”</a:t>
-            </a:r>
-          </a:p>
-          <a:p>
-            <a:pPr marL="254000" indent="-254000" algn="l">
-              <a:buClr>
-                <a:srgbClr val="000000"/>
-              </a:buClr>
-              <a:buSzPct val="100000"/>
-              <a:buAutoNum type="arabicPeriod" startAt="1"/>
-              <a:defRPr sz="1400">
-                <a:solidFill>
-                  <a:srgbClr val="000000"/>
-                </a:solidFill>
-                <a:latin typeface="Lucida Grande"/>
-                <a:ea typeface="Lucida Grande"/>
-                <a:cs typeface="Lucida Grande"/>
-                <a:sym typeface="Lucida Grande"/>
-              </a:defRPr>
-            </a:pPr>
-            <a:r>
-              <a:t>“Do not allow a player to leave the penalty box.”</a:t>
             </a:r>
           </a:p>
           <a:p>
@@ -7956,37 +7935,6 @@
           <p:nvPr/>
         </p:nvSpPr>
         <p:spPr>
-          <a:xfrm flipV="1">
-            <a:off x="-1" y="6465261"/>
-            <a:ext cx="24384002" cy="1"/>
-          </a:xfrm>
-          <a:prstGeom prst="line">
-            <a:avLst/>
-          </a:prstGeom>
-          <a:ln w="25400" cap="rnd">
-            <a:solidFill>
-              <a:srgbClr val="000000"/>
-            </a:solidFill>
-            <a:custDash>
-              <a:ds d="100000" sp="200000"/>
-            </a:custDash>
-          </a:ln>
-        </p:spPr>
-        <p:txBody>
-          <a:bodyPr lIns="50800" tIns="50800" rIns="50800" bIns="50800" anchor="ctr"/>
-          <a:lstStyle/>
-          <a:p>
-            <a:pPr/>
-          </a:p>
-        </p:txBody>
-      </p:sp>
-      <p:sp>
-        <p:nvSpPr>
-          <p:cNvPr id="181" name="Line"/>
-          <p:cNvSpPr/>
-          <p:nvPr/>
-        </p:nvSpPr>
-        <p:spPr>
           <a:xfrm flipH="1">
             <a:off x="12191999" y="0"/>
             <a:ext cx="2" cy="13716000"/>
@@ -8013,7 +7961,7 @@
       </p:sp>
       <p:sp>
         <p:nvSpPr>
-          <p:cNvPr id="182" name="Rectangle"/>
+          <p:cNvPr id="181" name="Rectangle"/>
           <p:cNvSpPr/>
           <p:nvPr/>
         </p:nvSpPr>
@@ -8055,7 +8003,7 @@
       </p:sp>
       <p:sp>
         <p:nvSpPr>
-          <p:cNvPr id="183" name="Rectangle"/>
+          <p:cNvPr id="182" name="Rectangle"/>
           <p:cNvSpPr/>
           <p:nvPr/>
         </p:nvSpPr>
@@ -8097,7 +8045,7 @@
       </p:sp>
       <p:sp>
         <p:nvSpPr>
-          <p:cNvPr id="184" name="Coaches &amp; Captains Meeting"/>
+          <p:cNvPr id="183" name="Coaches &amp; Captains Meeting"/>
           <p:cNvSpPr txBox="1"/>
           <p:nvPr/>
         </p:nvSpPr>
@@ -8143,7 +8091,7 @@
       </p:sp>
       <p:sp>
         <p:nvSpPr>
-          <p:cNvPr id="185" name="Coaches &amp; Captains Meeting Continued"/>
+          <p:cNvPr id="184" name="Coaches &amp; Captains Meeting Continued"/>
           <p:cNvSpPr txBox="1"/>
           <p:nvPr/>
         </p:nvSpPr>
@@ -8189,7 +8137,7 @@
       </p:sp>
       <p:sp>
         <p:nvSpPr>
-          <p:cNvPr id="186" name="Medical benches…"/>
+          <p:cNvPr id="185" name="Medical benches…"/>
           <p:cNvSpPr txBox="1"/>
           <p:nvPr/>
         </p:nvSpPr>
@@ -8392,7 +8340,7 @@
       </p:sp>
       <p:sp>
         <p:nvSpPr>
-          <p:cNvPr id="187" name="Game Administration"/>
+          <p:cNvPr id="186" name="Game Administration"/>
           <p:cNvSpPr txBox="1"/>
           <p:nvPr/>
         </p:nvSpPr>
@@ -8438,7 +8386,7 @@
       </p:sp>
       <p:sp>
         <p:nvSpPr>
-          <p:cNvPr id="188" name="If you have an official review available, I will ask you if you want to use it at the end of each period.…"/>
+          <p:cNvPr id="187" name="If you have an official review available, I will ask you if you want to use it at the end of each period.…"/>
           <p:cNvSpPr txBox="1"/>
           <p:nvPr/>
         </p:nvSpPr>
@@ -8511,7 +8459,7 @@
       </p:sp>
       <p:sp>
         <p:nvSpPr>
-          <p:cNvPr id="189" name="End-of-Period and Game Procedures"/>
+          <p:cNvPr id="188" name="End-of-Period and Game Procedures"/>
           <p:cNvSpPr txBox="1"/>
           <p:nvPr/>
         </p:nvSpPr>
@@ -8557,7 +8505,7 @@
       </p:sp>
       <p:sp>
         <p:nvSpPr>
-          <p:cNvPr id="190" name="Penalty avoidance:…"/>
+          <p:cNvPr id="189" name="Penalty avoidance:…"/>
           <p:cNvSpPr txBox="1"/>
           <p:nvPr/>
         </p:nvSpPr>
@@ -9014,7 +8962,7 @@
       </p:sp>
       <p:sp>
         <p:nvSpPr>
-          <p:cNvPr id="191" name="Gameplay Support"/>
+          <p:cNvPr id="190" name="Gameplay Support"/>
           <p:cNvSpPr txBox="1"/>
           <p:nvPr/>
         </p:nvSpPr>
@@ -9060,7 +9008,7 @@
       </p:sp>
       <p:sp>
         <p:nvSpPr>
-          <p:cNvPr id="192" name="Captains and Alternates only for both teams, please meet at the designated official review area.…"/>
+          <p:cNvPr id="191" name="Captains and Alternates only for both teams, please meet at the designated official review area.…"/>
           <p:cNvSpPr txBox="1"/>
           <p:nvPr/>
         </p:nvSpPr>
@@ -9164,7 +9112,7 @@
       </p:sp>
       <p:sp>
         <p:nvSpPr>
-          <p:cNvPr id="193" name="Official Reviews"/>
+          <p:cNvPr id="192" name="Official Reviews"/>
           <p:cNvSpPr txBox="1"/>
           <p:nvPr/>
         </p:nvSpPr>
@@ -9210,7 +9158,7 @@
       </p:sp>
       <p:sp>
         <p:nvSpPr>
-          <p:cNvPr id="194" name="Players and coaches may ask any SO short, clarifying questions (≈5-8 seconds) during lineups, timeouts, etc.…"/>
+          <p:cNvPr id="193" name="Players and coaches may ask any SO short, clarifying questions (≈5-8 seconds) during lineups, timeouts, etc.…"/>
           <p:cNvSpPr txBox="1"/>
           <p:nvPr/>
         </p:nvSpPr>
@@ -9307,7 +9255,7 @@
       </p:sp>
       <p:sp>
         <p:nvSpPr>
-          <p:cNvPr id="195" name="Communication With Officials"/>
+          <p:cNvPr id="194" name="Communication With Officials"/>
           <p:cNvSpPr txBox="1"/>
           <p:nvPr/>
         </p:nvSpPr>
@@ -9353,7 +9301,7 @@
       </p:sp>
       <p:sp>
         <p:nvSpPr>
-          <p:cNvPr id="196" name="If the scoreboard indicates a tie score at the end of regulation after the JRs check in with their SKs, the SBO will immediately start a one-minute lineup clock (counting up).…"/>
+          <p:cNvPr id="195" name="If the scoreboard indicates a tie score at the end of regulation after the JRs check in with their SKs, the SBO will immediately start a one-minute lineup clock (counting up).…"/>
           <p:cNvSpPr txBox="1"/>
           <p:nvPr/>
         </p:nvSpPr>
@@ -9513,7 +9461,7 @@
       </p:sp>
       <p:sp>
         <p:nvSpPr>
-          <p:cNvPr id="197" name="Overtime Procedures"/>
+          <p:cNvPr id="196" name="Overtime Procedures"/>
           <p:cNvSpPr txBox="1"/>
           <p:nvPr/>
         </p:nvSpPr>
@@ -9559,28 +9507,1183 @@
       </p:sp>
       <p:grpSp>
         <p:nvGrpSpPr>
-          <p:cNvPr id="217" name="Track"/>
+          <p:cNvPr id="232" name="Group"/>
           <p:cNvGrpSpPr/>
           <p:nvPr/>
         </p:nvGrpSpPr>
         <p:grpSpPr>
-          <a:xfrm rot="16199601">
-            <a:off x="11863616" y="3131864"/>
-            <a:ext cx="12422788" cy="8468256"/>
-            <a:chOff x="0" y="-1"/>
-            <a:chExt cx="12422786" cy="8468254"/>
+          <a:xfrm rot="16197861">
+            <a:off x="12554669" y="2114214"/>
+            <a:ext cx="12596172" cy="9894238"/>
+            <a:chOff x="-18" y="4"/>
+            <a:chExt cx="12596170" cy="9894236"/>
           </a:xfrm>
         </p:grpSpPr>
+        <p:grpSp>
+          <p:nvGrpSpPr>
+            <p:cNvPr id="216" name="Track"/>
+            <p:cNvGrpSpPr/>
+            <p:nvPr/>
+          </p:nvGrpSpPr>
+          <p:grpSpPr>
+            <a:xfrm rot="10799600">
+              <a:off x="481" y="738"/>
+              <a:ext cx="12595170" cy="8596202"/>
+              <a:chOff x="-1" y="-2"/>
+              <a:chExt cx="12595169" cy="8596200"/>
+            </a:xfrm>
+          </p:grpSpPr>
+          <p:sp>
+            <p:nvSpPr>
+              <p:cNvPr id="197" name="Bumpers"/>
+              <p:cNvSpPr/>
+              <p:nvPr/>
+            </p:nvSpPr>
+            <p:spPr>
+              <a:xfrm rot="21600000">
+                <a:off x="-1" y="-1"/>
+                <a:ext cx="12595168" cy="8596199"/>
+              </a:xfrm>
+              <a:custGeom>
+                <a:avLst/>
+                <a:gdLst/>
+                <a:ahLst/>
+                <a:cxnLst>
+                  <a:cxn ang="0">
+                    <a:pos x="wd2" y="hd2"/>
+                  </a:cxn>
+                  <a:cxn ang="5400000">
+                    <a:pos x="wd2" y="hd2"/>
+                  </a:cxn>
+                  <a:cxn ang="10800000">
+                    <a:pos x="wd2" y="hd2"/>
+                  </a:cxn>
+                  <a:cxn ang="16200000">
+                    <a:pos x="wd2" y="hd2"/>
+                  </a:cxn>
+                </a:cxnLst>
+                <a:rect l="0" t="0" r="r" b="b"/>
+                <a:pathLst>
+                  <a:path w="21486" h="21591" fill="norm" stroke="1" extrusionOk="0">
+                    <a:moveTo>
+                      <a:pt x="14355" y="1"/>
+                    </a:moveTo>
+                    <a:cubicBezTo>
+                      <a:pt x="14184" y="3"/>
+                      <a:pt x="14013" y="11"/>
+                      <a:pt x="13843" y="26"/>
+                    </a:cubicBezTo>
+                    <a:cubicBezTo>
+                      <a:pt x="13835" y="30"/>
+                      <a:pt x="13826" y="34"/>
+                      <a:pt x="13818" y="38"/>
+                    </a:cubicBezTo>
+                    <a:cubicBezTo>
+                      <a:pt x="13810" y="41"/>
+                      <a:pt x="13802" y="46"/>
+                      <a:pt x="13793" y="49"/>
+                    </a:cubicBezTo>
+                    <a:lnTo>
+                      <a:pt x="13792" y="32"/>
+                    </a:lnTo>
+                    <a:lnTo>
+                      <a:pt x="7548" y="539"/>
+                    </a:lnTo>
+                    <a:cubicBezTo>
+                      <a:pt x="6643" y="569"/>
+                      <a:pt x="5744" y="784"/>
+                      <a:pt x="4872" y="1174"/>
+                    </a:cubicBezTo>
+                    <a:cubicBezTo>
+                      <a:pt x="3433" y="1816"/>
+                      <a:pt x="2050" y="2938"/>
+                      <a:pt x="1143" y="4895"/>
+                    </a:cubicBezTo>
+                    <a:cubicBezTo>
+                      <a:pt x="94" y="7158"/>
+                      <a:pt x="-113" y="10020"/>
+                      <a:pt x="50" y="12758"/>
+                    </a:cubicBezTo>
+                    <a:cubicBezTo>
+                      <a:pt x="129" y="14081"/>
+                      <a:pt x="295" y="15418"/>
+                      <a:pt x="650" y="16641"/>
+                    </a:cubicBezTo>
+                    <a:cubicBezTo>
+                      <a:pt x="969" y="17743"/>
+                      <a:pt x="1437" y="18729"/>
+                      <a:pt x="2030" y="19522"/>
+                    </a:cubicBezTo>
+                    <a:cubicBezTo>
+                      <a:pt x="2668" y="20376"/>
+                      <a:pt x="3375" y="20932"/>
+                      <a:pt x="4119" y="21234"/>
+                    </a:cubicBezTo>
+                    <a:cubicBezTo>
+                      <a:pt x="4856" y="21534"/>
+                      <a:pt x="5617" y="21582"/>
+                      <a:pt x="6345" y="21591"/>
+                    </a:cubicBezTo>
+                    <a:cubicBezTo>
+                      <a:pt x="7075" y="21599"/>
+                      <a:pt x="7808" y="21561"/>
+                      <a:pt x="8544" y="21466"/>
+                    </a:cubicBezTo>
+                    <a:lnTo>
+                      <a:pt x="14566" y="21002"/>
+                    </a:lnTo>
+                    <a:lnTo>
+                      <a:pt x="14566" y="21002"/>
+                    </a:lnTo>
+                    <a:cubicBezTo>
+                      <a:pt x="14676" y="21007"/>
+                      <a:pt x="14786" y="20988"/>
+                      <a:pt x="14896" y="20966"/>
+                    </a:cubicBezTo>
+                    <a:cubicBezTo>
+                      <a:pt x="15005" y="20944"/>
+                      <a:pt x="15114" y="20919"/>
+                      <a:pt x="15224" y="20894"/>
+                    </a:cubicBezTo>
+                    <a:cubicBezTo>
+                      <a:pt x="16033" y="20716"/>
+                      <a:pt x="16838" y="20385"/>
+                      <a:pt x="17608" y="19879"/>
+                    </a:cubicBezTo>
+                    <a:cubicBezTo>
+                      <a:pt x="18367" y="19381"/>
+                      <a:pt x="19101" y="18707"/>
+                      <a:pt x="19717" y="17744"/>
+                    </a:cubicBezTo>
+                    <a:cubicBezTo>
+                      <a:pt x="20970" y="15786"/>
+                      <a:pt x="21485" y="13153"/>
+                      <a:pt x="21486" y="10553"/>
+                    </a:cubicBezTo>
+                    <a:cubicBezTo>
+                      <a:pt x="21487" y="7871"/>
+                      <a:pt x="20944" y="5084"/>
+                      <a:pt x="19644" y="3018"/>
+                    </a:cubicBezTo>
+                    <a:cubicBezTo>
+                      <a:pt x="18371" y="996"/>
+                      <a:pt x="16615" y="141"/>
+                      <a:pt x="14866" y="16"/>
+                    </a:cubicBezTo>
+                    <a:cubicBezTo>
+                      <a:pt x="14696" y="4"/>
+                      <a:pt x="14525" y="-1"/>
+                      <a:pt x="14355" y="1"/>
+                    </a:cubicBezTo>
+                    <a:close/>
+                  </a:path>
+                </a:pathLst>
+              </a:custGeom>
+              <a:noFill/>
+              <a:ln w="63500" cap="flat">
+                <a:solidFill>
+                  <a:srgbClr val="000000"/>
+                </a:solidFill>
+                <a:prstDash val="solid"/>
+                <a:miter lim="400000"/>
+              </a:ln>
+              <a:effectLst/>
+              <a:extLst>
+                <a:ext uri="{C572A759-6A51-4108-AA02-DFA0A04FC94B}">
+                  <ma14:wrappingTextBoxFlag xmlns:ma14="http://schemas.microsoft.com/office/mac/drawingml/2011/main" val="1"/>
+                </a:ext>
+              </a:extLst>
+            </p:spPr>
+            <p:txBody>
+              <a:bodyPr wrap="square" lIns="50800" tIns="50800" rIns="50800" bIns="50800" numCol="1" anchor="ctr">
+                <a:noAutofit/>
+              </a:bodyPr>
+              <a:lstStyle>
+                <a:lvl1pPr defTabSz="825500">
+                  <a:defRPr sz="3200">
+                    <a:solidFill>
+                      <a:srgbClr val="FFFFFF"/>
+                    </a:solidFill>
+                    <a:latin typeface="Helvetica Neue Medium"/>
+                    <a:ea typeface="Helvetica Neue Medium"/>
+                    <a:cs typeface="Helvetica Neue Medium"/>
+                    <a:sym typeface="Helvetica Neue Medium"/>
+                  </a:defRPr>
+                </a:lvl1pPr>
+              </a:lstStyle>
+              <a:p>
+                <a:pPr/>
+                <a:r>
+                  <a:t>]\</a:t>
+                </a:r>
+              </a:p>
+            </p:txBody>
+          </p:sp>
+          <p:sp>
+            <p:nvSpPr>
+              <p:cNvPr id="198" name="Outside Boundary"/>
+              <p:cNvSpPr/>
+              <p:nvPr/>
+            </p:nvSpPr>
+            <p:spPr>
+              <a:xfrm rot="21600000">
+                <a:off x="1178232" y="1092415"/>
+                <a:ext cx="10238702" cy="6411367"/>
+              </a:xfrm>
+              <a:custGeom>
+                <a:avLst/>
+                <a:gdLst/>
+                <a:ahLst/>
+                <a:cxnLst>
+                  <a:cxn ang="0">
+                    <a:pos x="wd2" y="hd2"/>
+                  </a:cxn>
+                  <a:cxn ang="5400000">
+                    <a:pos x="wd2" y="hd2"/>
+                  </a:cxn>
+                  <a:cxn ang="10800000">
+                    <a:pos x="wd2" y="hd2"/>
+                  </a:cxn>
+                  <a:cxn ang="16200000">
+                    <a:pos x="wd2" y="hd2"/>
+                  </a:cxn>
+                </a:cxnLst>
+                <a:rect l="0" t="0" r="r" b="b"/>
+                <a:pathLst>
+                  <a:path w="21482" h="21591" fill="norm" stroke="1" extrusionOk="0">
+                    <a:moveTo>
+                      <a:pt x="14352" y="1"/>
+                    </a:moveTo>
+                    <a:cubicBezTo>
+                      <a:pt x="14182" y="3"/>
+                      <a:pt x="14011" y="11"/>
+                      <a:pt x="13841" y="26"/>
+                    </a:cubicBezTo>
+                    <a:cubicBezTo>
+                      <a:pt x="13824" y="33"/>
+                      <a:pt x="13808" y="42"/>
+                      <a:pt x="13791" y="49"/>
+                    </a:cubicBezTo>
+                    <a:lnTo>
+                      <a:pt x="13790" y="32"/>
+                    </a:lnTo>
+                    <a:lnTo>
+                      <a:pt x="7547" y="538"/>
+                    </a:lnTo>
+                    <a:cubicBezTo>
+                      <a:pt x="6642" y="569"/>
+                      <a:pt x="5743" y="784"/>
+                      <a:pt x="4871" y="1173"/>
+                    </a:cubicBezTo>
+                    <a:cubicBezTo>
+                      <a:pt x="3432" y="1816"/>
+                      <a:pt x="2050" y="2937"/>
+                      <a:pt x="1143" y="4895"/>
+                    </a:cubicBezTo>
+                    <a:cubicBezTo>
+                      <a:pt x="94" y="7158"/>
+                      <a:pt x="-113" y="10020"/>
+                      <a:pt x="50" y="12758"/>
+                    </a:cubicBezTo>
+                    <a:cubicBezTo>
+                      <a:pt x="129" y="14081"/>
+                      <a:pt x="295" y="15418"/>
+                      <a:pt x="650" y="16641"/>
+                    </a:cubicBezTo>
+                    <a:cubicBezTo>
+                      <a:pt x="969" y="17743"/>
+                      <a:pt x="1437" y="18729"/>
+                      <a:pt x="2029" y="19522"/>
+                    </a:cubicBezTo>
+                    <a:cubicBezTo>
+                      <a:pt x="2667" y="20376"/>
+                      <a:pt x="3374" y="20932"/>
+                      <a:pt x="4118" y="21234"/>
+                    </a:cubicBezTo>
+                    <a:cubicBezTo>
+                      <a:pt x="4855" y="21534"/>
+                      <a:pt x="5616" y="21582"/>
+                      <a:pt x="6344" y="21591"/>
+                    </a:cubicBezTo>
+                    <a:cubicBezTo>
+                      <a:pt x="7074" y="21599"/>
+                      <a:pt x="7807" y="21561"/>
+                      <a:pt x="8543" y="21466"/>
+                    </a:cubicBezTo>
+                    <a:lnTo>
+                      <a:pt x="14563" y="21002"/>
+                    </a:lnTo>
+                    <a:cubicBezTo>
+                      <a:pt x="14563" y="21002"/>
+                      <a:pt x="14564" y="21002"/>
+                      <a:pt x="14564" y="21002"/>
+                    </a:cubicBezTo>
+                    <a:cubicBezTo>
+                      <a:pt x="14789" y="21013"/>
+                      <a:pt x="15015" y="21000"/>
+                      <a:pt x="15241" y="20966"/>
+                    </a:cubicBezTo>
+                    <a:cubicBezTo>
+                      <a:pt x="16054" y="20843"/>
+                      <a:pt x="16844" y="20420"/>
+                      <a:pt x="17605" y="19879"/>
+                    </a:cubicBezTo>
+                    <a:cubicBezTo>
+                      <a:pt x="18351" y="19349"/>
+                      <a:pt x="19091" y="18698"/>
+                      <a:pt x="19714" y="17744"/>
+                    </a:cubicBezTo>
+                    <a:cubicBezTo>
+                      <a:pt x="20982" y="15803"/>
+                      <a:pt x="21487" y="13156"/>
+                      <a:pt x="21483" y="10553"/>
+                    </a:cubicBezTo>
+                    <a:cubicBezTo>
+                      <a:pt x="21478" y="7873"/>
+                      <a:pt x="20939" y="5084"/>
+                      <a:pt x="19640" y="3018"/>
+                    </a:cubicBezTo>
+                    <a:cubicBezTo>
+                      <a:pt x="18369" y="994"/>
+                      <a:pt x="16612" y="141"/>
+                      <a:pt x="14863" y="16"/>
+                    </a:cubicBezTo>
+                    <a:cubicBezTo>
+                      <a:pt x="14693" y="4"/>
+                      <a:pt x="14523" y="-1"/>
+                      <a:pt x="14352" y="1"/>
+                    </a:cubicBezTo>
+                    <a:close/>
+                  </a:path>
+                </a:pathLst>
+              </a:custGeom>
+              <a:solidFill>
+                <a:srgbClr val="FFFFFF"/>
+              </a:solidFill>
+              <a:ln w="63500" cap="flat">
+                <a:solidFill>
+                  <a:srgbClr val="0433FF"/>
+                </a:solidFill>
+                <a:prstDash val="solid"/>
+                <a:miter lim="400000"/>
+              </a:ln>
+              <a:effectLst/>
+            </p:spPr>
+            <p:txBody>
+              <a:bodyPr wrap="square" lIns="50800" tIns="50800" rIns="50800" bIns="50800" numCol="1" anchor="ctr">
+                <a:noAutofit/>
+              </a:bodyPr>
+              <a:lstStyle/>
+              <a:p>
+                <a:pPr defTabSz="825500">
+                  <a:defRPr sz="3200">
+                    <a:solidFill>
+                      <a:srgbClr val="FFFFFF"/>
+                    </a:solidFill>
+                    <a:latin typeface="Helvetica Neue Medium"/>
+                    <a:ea typeface="Helvetica Neue Medium"/>
+                    <a:cs typeface="Helvetica Neue Medium"/>
+                    <a:sym typeface="Helvetica Neue Medium"/>
+                  </a:defRPr>
+                </a:pPr>
+              </a:p>
+            </p:txBody>
+          </p:sp>
+          <p:sp>
+            <p:nvSpPr>
+              <p:cNvPr id="199" name="Inside Boundary"/>
+              <p:cNvSpPr/>
+              <p:nvPr/>
+            </p:nvSpPr>
+            <p:spPr>
+              <a:xfrm rot="21600000">
+                <a:off x="2777755" y="2839253"/>
+                <a:ext cx="7003570" cy="2908559"/>
+              </a:xfrm>
+              <a:prstGeom prst="roundRect">
+                <a:avLst>
+                  <a:gd name="adj" fmla="val 48362"/>
+                </a:avLst>
+              </a:prstGeom>
+              <a:solidFill>
+                <a:srgbClr val="D6D6D6"/>
+              </a:solidFill>
+              <a:ln w="63500" cap="flat">
+                <a:solidFill>
+                  <a:srgbClr val="0433FF"/>
+                </a:solidFill>
+                <a:prstDash val="solid"/>
+                <a:miter lim="400000"/>
+              </a:ln>
+              <a:effectLst/>
+            </p:spPr>
+            <p:txBody>
+              <a:bodyPr wrap="square" lIns="50800" tIns="50800" rIns="50800" bIns="50800" numCol="1" anchor="ctr">
+                <a:noAutofit/>
+              </a:bodyPr>
+              <a:lstStyle/>
+              <a:p>
+                <a:pPr defTabSz="825500">
+                  <a:defRPr sz="3200">
+                    <a:solidFill>
+                      <a:srgbClr val="FFFFFF"/>
+                    </a:solidFill>
+                    <a:latin typeface="Helvetica Neue Medium"/>
+                    <a:ea typeface="Helvetica Neue Medium"/>
+                    <a:cs typeface="Helvetica Neue Medium"/>
+                    <a:sym typeface="Helvetica Neue Medium"/>
+                  </a:defRPr>
+                </a:pPr>
+              </a:p>
+            </p:txBody>
+          </p:sp>
+          <p:sp>
+            <p:nvSpPr>
+              <p:cNvPr id="200" name="Pivot Line"/>
+              <p:cNvSpPr/>
+              <p:nvPr/>
+            </p:nvSpPr>
+            <p:spPr>
+              <a:xfrm flipV="1">
+                <a:off x="4273128" y="1273770"/>
+                <a:ext cx="1" cy="1567505"/>
+              </a:xfrm>
+              <a:prstGeom prst="line">
+                <a:avLst/>
+              </a:prstGeom>
+              <a:noFill/>
+              <a:ln w="63500" cap="flat">
+                <a:solidFill>
+                  <a:srgbClr val="0433FF"/>
+                </a:solidFill>
+                <a:prstDash val="solid"/>
+                <a:miter lim="400000"/>
+              </a:ln>
+              <a:effectLst/>
+            </p:spPr>
+            <p:txBody>
+              <a:bodyPr wrap="square" lIns="50800" tIns="50800" rIns="50800" bIns="50800" numCol="1" anchor="ctr">
+                <a:noAutofit/>
+              </a:bodyPr>
+              <a:lstStyle/>
+              <a:p>
+                <a:pPr algn="l">
+                  <a:lnSpc>
+                    <a:spcPct val="90000"/>
+                  </a:lnSpc>
+                  <a:spcBef>
+                    <a:spcPts val="4500"/>
+                  </a:spcBef>
+                  <a:defRPr sz="4800">
+                    <a:solidFill>
+                      <a:srgbClr val="000000"/>
+                    </a:solidFill>
+                  </a:defRPr>
+                </a:pPr>
+              </a:p>
+            </p:txBody>
+          </p:sp>
+          <p:sp>
+            <p:nvSpPr>
+              <p:cNvPr id="201" name="Jammer Line"/>
+              <p:cNvSpPr/>
+              <p:nvPr/>
+            </p:nvSpPr>
+            <p:spPr>
+              <a:xfrm flipV="1">
+                <a:off x="7752241" y="1094227"/>
+                <a:ext cx="2" cy="1724143"/>
+              </a:xfrm>
+              <a:prstGeom prst="line">
+                <a:avLst/>
+              </a:prstGeom>
+              <a:noFill/>
+              <a:ln w="63500" cap="flat">
+                <a:solidFill>
+                  <a:srgbClr val="0433FF"/>
+                </a:solidFill>
+                <a:prstDash val="solid"/>
+                <a:miter lim="400000"/>
+              </a:ln>
+              <a:effectLst/>
+            </p:spPr>
+            <p:txBody>
+              <a:bodyPr wrap="square" lIns="50800" tIns="50800" rIns="50800" bIns="50800" numCol="1" anchor="ctr">
+                <a:noAutofit/>
+              </a:bodyPr>
+              <a:lstStyle/>
+              <a:p>
+                <a:pPr algn="l">
+                  <a:lnSpc>
+                    <a:spcPct val="90000"/>
+                  </a:lnSpc>
+                  <a:spcBef>
+                    <a:spcPts val="4500"/>
+                  </a:spcBef>
+                  <a:defRPr sz="4800">
+                    <a:solidFill>
+                      <a:srgbClr val="000000"/>
+                    </a:solidFill>
+                  </a:defRPr>
+                </a:pPr>
+              </a:p>
+            </p:txBody>
+          </p:sp>
+          <p:sp>
+            <p:nvSpPr>
+              <p:cNvPr id="202" name="Line"/>
+              <p:cNvSpPr/>
+              <p:nvPr/>
+            </p:nvSpPr>
+            <p:spPr>
+              <a:xfrm flipH="1" flipV="1">
+                <a:off x="2972724" y="2285423"/>
+                <a:ext cx="236214" cy="331828"/>
+              </a:xfrm>
+              <a:prstGeom prst="line">
+                <a:avLst/>
+              </a:prstGeom>
+              <a:noFill/>
+              <a:ln w="63500" cap="flat">
+                <a:solidFill>
+                  <a:srgbClr val="0433FF"/>
+                </a:solidFill>
+                <a:prstDash val="solid"/>
+                <a:miter lim="400000"/>
+              </a:ln>
+              <a:effectLst/>
+            </p:spPr>
+            <p:txBody>
+              <a:bodyPr wrap="square" lIns="50800" tIns="50800" rIns="50800" bIns="50800" numCol="1" anchor="ctr">
+                <a:noAutofit/>
+              </a:bodyPr>
+              <a:lstStyle/>
+              <a:p>
+                <a:pPr algn="l">
+                  <a:lnSpc>
+                    <a:spcPct val="90000"/>
+                  </a:lnSpc>
+                  <a:spcBef>
+                    <a:spcPts val="4500"/>
+                  </a:spcBef>
+                  <a:defRPr sz="4800">
+                    <a:solidFill>
+                      <a:srgbClr val="000000"/>
+                    </a:solidFill>
+                  </a:defRPr>
+                </a:pPr>
+              </a:p>
+            </p:txBody>
+          </p:sp>
+          <p:sp>
+            <p:nvSpPr>
+              <p:cNvPr id="203" name="Line"/>
+              <p:cNvSpPr/>
+              <p:nvPr/>
+            </p:nvSpPr>
+            <p:spPr>
+              <a:xfrm flipH="1" flipV="1">
+                <a:off x="1938741" y="3581983"/>
+                <a:ext cx="367218" cy="175524"/>
+              </a:xfrm>
+              <a:prstGeom prst="line">
+                <a:avLst/>
+              </a:prstGeom>
+              <a:noFill/>
+              <a:ln w="63500" cap="flat">
+                <a:solidFill>
+                  <a:srgbClr val="0433FF"/>
+                </a:solidFill>
+                <a:prstDash val="solid"/>
+                <a:miter lim="400000"/>
+              </a:ln>
+              <a:effectLst/>
+            </p:spPr>
+            <p:txBody>
+              <a:bodyPr wrap="square" lIns="50800" tIns="50800" rIns="50800" bIns="50800" numCol="1" anchor="ctr">
+                <a:noAutofit/>
+              </a:bodyPr>
+              <a:lstStyle/>
+              <a:p>
+                <a:pPr algn="l">
+                  <a:lnSpc>
+                    <a:spcPct val="90000"/>
+                  </a:lnSpc>
+                  <a:spcBef>
+                    <a:spcPts val="4500"/>
+                  </a:spcBef>
+                  <a:defRPr sz="4800">
+                    <a:solidFill>
+                      <a:srgbClr val="000000"/>
+                    </a:solidFill>
+                  </a:defRPr>
+                </a:pPr>
+              </a:p>
+            </p:txBody>
+          </p:sp>
+          <p:sp>
+            <p:nvSpPr>
+              <p:cNvPr id="204" name="Line"/>
+              <p:cNvSpPr/>
+              <p:nvPr/>
+            </p:nvSpPr>
+            <p:spPr>
+              <a:xfrm flipH="1">
+                <a:off x="1807593" y="4913212"/>
+                <a:ext cx="403421" cy="53111"/>
+              </a:xfrm>
+              <a:prstGeom prst="line">
+                <a:avLst/>
+              </a:prstGeom>
+              <a:noFill/>
+              <a:ln w="63500" cap="flat">
+                <a:solidFill>
+                  <a:srgbClr val="0433FF"/>
+                </a:solidFill>
+                <a:prstDash val="solid"/>
+                <a:miter lim="400000"/>
+              </a:ln>
+              <a:effectLst/>
+            </p:spPr>
+            <p:txBody>
+              <a:bodyPr wrap="square" lIns="50800" tIns="50800" rIns="50800" bIns="50800" numCol="1" anchor="ctr">
+                <a:noAutofit/>
+              </a:bodyPr>
+              <a:lstStyle/>
+              <a:p>
+                <a:pPr algn="l">
+                  <a:lnSpc>
+                    <a:spcPct val="90000"/>
+                  </a:lnSpc>
+                  <a:spcBef>
+                    <a:spcPts val="4500"/>
+                  </a:spcBef>
+                  <a:defRPr sz="4800">
+                    <a:solidFill>
+                      <a:srgbClr val="000000"/>
+                    </a:solidFill>
+                  </a:defRPr>
+                </a:pPr>
+              </a:p>
+            </p:txBody>
+          </p:sp>
+          <p:sp>
+            <p:nvSpPr>
+              <p:cNvPr id="205" name="Line"/>
+              <p:cNvSpPr/>
+              <p:nvPr/>
+            </p:nvSpPr>
+            <p:spPr>
+              <a:xfrm flipV="1">
+                <a:off x="2326198" y="6036457"/>
+                <a:ext cx="295090" cy="280589"/>
+              </a:xfrm>
+              <a:prstGeom prst="line">
+                <a:avLst/>
+              </a:prstGeom>
+              <a:noFill/>
+              <a:ln w="63500" cap="flat">
+                <a:solidFill>
+                  <a:srgbClr val="0433FF"/>
+                </a:solidFill>
+                <a:prstDash val="solid"/>
+                <a:miter lim="400000"/>
+              </a:ln>
+              <a:effectLst/>
+            </p:spPr>
+            <p:txBody>
+              <a:bodyPr wrap="square" lIns="50800" tIns="50800" rIns="50800" bIns="50800" numCol="1" anchor="ctr">
+                <a:noAutofit/>
+              </a:bodyPr>
+              <a:lstStyle/>
+              <a:p>
+                <a:pPr algn="l">
+                  <a:lnSpc>
+                    <a:spcPct val="90000"/>
+                  </a:lnSpc>
+                  <a:spcBef>
+                    <a:spcPts val="4500"/>
+                  </a:spcBef>
+                  <a:defRPr sz="4800">
+                    <a:solidFill>
+                      <a:srgbClr val="000000"/>
+                    </a:solidFill>
+                  </a:defRPr>
+                </a:pPr>
+              </a:p>
+            </p:txBody>
+          </p:sp>
+          <p:sp>
+            <p:nvSpPr>
+              <p:cNvPr id="206" name="Line"/>
+              <p:cNvSpPr/>
+              <p:nvPr/>
+            </p:nvSpPr>
+            <p:spPr>
+              <a:xfrm flipV="1">
+                <a:off x="3562137" y="6402810"/>
+                <a:ext cx="60060" cy="403069"/>
+              </a:xfrm>
+              <a:prstGeom prst="line">
+                <a:avLst/>
+              </a:prstGeom>
+              <a:noFill/>
+              <a:ln w="63500" cap="flat">
+                <a:solidFill>
+                  <a:srgbClr val="0433FF"/>
+                </a:solidFill>
+                <a:prstDash val="solid"/>
+                <a:miter lim="400000"/>
+              </a:ln>
+              <a:effectLst/>
+            </p:spPr>
+            <p:txBody>
+              <a:bodyPr wrap="square" lIns="50800" tIns="50800" rIns="50800" bIns="50800" numCol="1" anchor="ctr">
+                <a:noAutofit/>
+              </a:bodyPr>
+              <a:lstStyle/>
+              <a:p>
+                <a:pPr algn="l">
+                  <a:lnSpc>
+                    <a:spcPct val="90000"/>
+                  </a:lnSpc>
+                  <a:spcBef>
+                    <a:spcPts val="4500"/>
+                  </a:spcBef>
+                  <a:defRPr sz="4800">
+                    <a:solidFill>
+                      <a:srgbClr val="000000"/>
+                    </a:solidFill>
+                  </a:defRPr>
+                </a:pPr>
+              </a:p>
+            </p:txBody>
+          </p:sp>
+          <p:sp>
+            <p:nvSpPr>
+              <p:cNvPr id="207" name="Line"/>
+              <p:cNvSpPr/>
+              <p:nvPr/>
+            </p:nvSpPr>
+            <p:spPr>
+              <a:xfrm flipV="1">
+                <a:off x="4827424" y="6436111"/>
+                <a:ext cx="1" cy="407534"/>
+              </a:xfrm>
+              <a:prstGeom prst="line">
+                <a:avLst/>
+              </a:prstGeom>
+              <a:noFill/>
+              <a:ln w="63500" cap="flat">
+                <a:solidFill>
+                  <a:srgbClr val="0433FF"/>
+                </a:solidFill>
+                <a:prstDash val="solid"/>
+                <a:miter lim="400000"/>
+              </a:ln>
+              <a:effectLst/>
+            </p:spPr>
+            <p:txBody>
+              <a:bodyPr wrap="square" lIns="50800" tIns="50800" rIns="50800" bIns="50800" numCol="1" anchor="ctr">
+                <a:noAutofit/>
+              </a:bodyPr>
+              <a:lstStyle/>
+              <a:p>
+                <a:pPr algn="l">
+                  <a:lnSpc>
+                    <a:spcPct val="90000"/>
+                  </a:lnSpc>
+                  <a:spcBef>
+                    <a:spcPts val="4500"/>
+                  </a:spcBef>
+                  <a:defRPr sz="4800">
+                    <a:solidFill>
+                      <a:srgbClr val="000000"/>
+                    </a:solidFill>
+                  </a:defRPr>
+                </a:pPr>
+              </a:p>
+            </p:txBody>
+          </p:sp>
+          <p:sp>
+            <p:nvSpPr>
+              <p:cNvPr id="208" name="Line"/>
+              <p:cNvSpPr/>
+              <p:nvPr/>
+            </p:nvSpPr>
+            <p:spPr>
+              <a:xfrm flipV="1">
+                <a:off x="5985975" y="6400578"/>
+                <a:ext cx="1" cy="407533"/>
+              </a:xfrm>
+              <a:prstGeom prst="line">
+                <a:avLst/>
+              </a:prstGeom>
+              <a:noFill/>
+              <a:ln w="63500" cap="flat">
+                <a:solidFill>
+                  <a:srgbClr val="0433FF"/>
+                </a:solidFill>
+                <a:prstDash val="solid"/>
+                <a:miter lim="400000"/>
+              </a:ln>
+              <a:effectLst/>
+            </p:spPr>
+            <p:txBody>
+              <a:bodyPr wrap="square" lIns="50800" tIns="50800" rIns="50800" bIns="50800" numCol="1" anchor="ctr">
+                <a:noAutofit/>
+              </a:bodyPr>
+              <a:lstStyle/>
+              <a:p>
+                <a:pPr algn="l">
+                  <a:lnSpc>
+                    <a:spcPct val="90000"/>
+                  </a:lnSpc>
+                  <a:spcBef>
+                    <a:spcPts val="4500"/>
+                  </a:spcBef>
+                  <a:defRPr sz="4800">
+                    <a:solidFill>
+                      <a:srgbClr val="000000"/>
+                    </a:solidFill>
+                  </a:defRPr>
+                </a:pPr>
+              </a:p>
+            </p:txBody>
+          </p:sp>
+          <p:sp>
+            <p:nvSpPr>
+              <p:cNvPr id="209" name="Line"/>
+              <p:cNvSpPr/>
+              <p:nvPr/>
+            </p:nvSpPr>
+            <p:spPr>
+              <a:xfrm flipV="1">
+                <a:off x="7162455" y="6400577"/>
+                <a:ext cx="1" cy="407534"/>
+              </a:xfrm>
+              <a:prstGeom prst="line">
+                <a:avLst/>
+              </a:prstGeom>
+              <a:noFill/>
+              <a:ln w="63500" cap="flat">
+                <a:solidFill>
+                  <a:srgbClr val="0433FF"/>
+                </a:solidFill>
+                <a:prstDash val="solid"/>
+                <a:miter lim="400000"/>
+              </a:ln>
+              <a:effectLst/>
+            </p:spPr>
+            <p:txBody>
+              <a:bodyPr wrap="square" lIns="50800" tIns="50800" rIns="50800" bIns="50800" numCol="1" anchor="ctr">
+                <a:noAutofit/>
+              </a:bodyPr>
+              <a:lstStyle/>
+              <a:p>
+                <a:pPr algn="l">
+                  <a:lnSpc>
+                    <a:spcPct val="90000"/>
+                  </a:lnSpc>
+                  <a:spcBef>
+                    <a:spcPts val="4500"/>
+                  </a:spcBef>
+                  <a:defRPr sz="4800">
+                    <a:solidFill>
+                      <a:srgbClr val="000000"/>
+                    </a:solidFill>
+                  </a:defRPr>
+                </a:pPr>
+              </a:p>
+            </p:txBody>
+          </p:sp>
+          <p:sp>
+            <p:nvSpPr>
+              <p:cNvPr id="210" name="Line"/>
+              <p:cNvSpPr/>
+              <p:nvPr/>
+            </p:nvSpPr>
+            <p:spPr>
+              <a:xfrm flipV="1">
+                <a:off x="8306354" y="6310788"/>
+                <a:ext cx="1" cy="407534"/>
+              </a:xfrm>
+              <a:prstGeom prst="line">
+                <a:avLst/>
+              </a:prstGeom>
+              <a:noFill/>
+              <a:ln w="63500" cap="flat">
+                <a:solidFill>
+                  <a:srgbClr val="0433FF"/>
+                </a:solidFill>
+                <a:prstDash val="solid"/>
+                <a:miter lim="400000"/>
+              </a:ln>
+              <a:effectLst/>
+            </p:spPr>
+            <p:txBody>
+              <a:bodyPr wrap="square" lIns="50800" tIns="50800" rIns="50800" bIns="50800" numCol="1" anchor="ctr">
+                <a:noAutofit/>
+              </a:bodyPr>
+              <a:lstStyle/>
+              <a:p>
+                <a:pPr algn="l">
+                  <a:lnSpc>
+                    <a:spcPct val="90000"/>
+                  </a:lnSpc>
+                  <a:spcBef>
+                    <a:spcPts val="4500"/>
+                  </a:spcBef>
+                  <a:defRPr sz="4800">
+                    <a:solidFill>
+                      <a:srgbClr val="000000"/>
+                    </a:solidFill>
+                  </a:defRPr>
+                </a:pPr>
+              </a:p>
+            </p:txBody>
+          </p:sp>
+          <p:sp>
+            <p:nvSpPr>
+              <p:cNvPr id="211" name="Line"/>
+              <p:cNvSpPr/>
+              <p:nvPr/>
+            </p:nvSpPr>
+            <p:spPr>
+              <a:xfrm flipH="1" flipV="1">
+                <a:off x="9386766" y="6025576"/>
+                <a:ext cx="256065" cy="316713"/>
+              </a:xfrm>
+              <a:prstGeom prst="line">
+                <a:avLst/>
+              </a:prstGeom>
+              <a:noFill/>
+              <a:ln w="63500" cap="flat">
+                <a:solidFill>
+                  <a:srgbClr val="0433FF"/>
+                </a:solidFill>
+                <a:prstDash val="solid"/>
+                <a:miter lim="400000"/>
+              </a:ln>
+              <a:effectLst/>
+            </p:spPr>
+            <p:txBody>
+              <a:bodyPr wrap="square" lIns="50800" tIns="50800" rIns="50800" bIns="50800" numCol="1" anchor="ctr">
+                <a:noAutofit/>
+              </a:bodyPr>
+              <a:lstStyle/>
+              <a:p>
+                <a:pPr algn="l">
+                  <a:lnSpc>
+                    <a:spcPct val="90000"/>
+                  </a:lnSpc>
+                  <a:spcBef>
+                    <a:spcPts val="4500"/>
+                  </a:spcBef>
+                  <a:defRPr sz="4800">
+                    <a:solidFill>
+                      <a:srgbClr val="000000"/>
+                    </a:solidFill>
+                  </a:defRPr>
+                </a:pPr>
+              </a:p>
+            </p:txBody>
+          </p:sp>
+          <p:sp>
+            <p:nvSpPr>
+              <p:cNvPr id="212" name="Line"/>
+              <p:cNvSpPr/>
+              <p:nvPr/>
+            </p:nvSpPr>
+            <p:spPr>
+              <a:xfrm flipH="1" flipV="1">
+                <a:off x="10198986" y="5159146"/>
+                <a:ext cx="379865" cy="146048"/>
+              </a:xfrm>
+              <a:prstGeom prst="line">
+                <a:avLst/>
+              </a:prstGeom>
+              <a:noFill/>
+              <a:ln w="63500" cap="flat">
+                <a:solidFill>
+                  <a:srgbClr val="0433FF"/>
+                </a:solidFill>
+                <a:prstDash val="solid"/>
+                <a:miter lim="400000"/>
+              </a:ln>
+              <a:effectLst/>
+            </p:spPr>
+            <p:txBody>
+              <a:bodyPr wrap="square" lIns="50800" tIns="50800" rIns="50800" bIns="50800" numCol="1" anchor="ctr">
+                <a:noAutofit/>
+              </a:bodyPr>
+              <a:lstStyle/>
+              <a:p>
+                <a:pPr algn="l">
+                  <a:lnSpc>
+                    <a:spcPct val="90000"/>
+                  </a:lnSpc>
+                  <a:spcBef>
+                    <a:spcPts val="4500"/>
+                  </a:spcBef>
+                  <a:defRPr sz="4800">
+                    <a:solidFill>
+                      <a:srgbClr val="000000"/>
+                    </a:solidFill>
+                  </a:defRPr>
+                </a:pPr>
+              </a:p>
+            </p:txBody>
+          </p:sp>
+          <p:sp>
+            <p:nvSpPr>
+              <p:cNvPr id="213" name="Line"/>
+              <p:cNvSpPr/>
+              <p:nvPr/>
+            </p:nvSpPr>
+            <p:spPr>
+              <a:xfrm flipH="1">
+                <a:off x="10416597" y="3904146"/>
+                <a:ext cx="396462" cy="91676"/>
+              </a:xfrm>
+              <a:prstGeom prst="line">
+                <a:avLst/>
+              </a:prstGeom>
+              <a:noFill/>
+              <a:ln w="63500" cap="flat">
+                <a:solidFill>
+                  <a:srgbClr val="0433FF"/>
+                </a:solidFill>
+                <a:prstDash val="solid"/>
+                <a:miter lim="400000"/>
+              </a:ln>
+              <a:effectLst/>
+            </p:spPr>
+            <p:txBody>
+              <a:bodyPr wrap="square" lIns="50800" tIns="50800" rIns="50800" bIns="50800" numCol="1" anchor="ctr">
+                <a:noAutofit/>
+              </a:bodyPr>
+              <a:lstStyle/>
+              <a:p>
+                <a:pPr algn="l">
+                  <a:lnSpc>
+                    <a:spcPct val="90000"/>
+                  </a:lnSpc>
+                  <a:spcBef>
+                    <a:spcPts val="4500"/>
+                  </a:spcBef>
+                  <a:defRPr sz="4800">
+                    <a:solidFill>
+                      <a:srgbClr val="000000"/>
+                    </a:solidFill>
+                  </a:defRPr>
+                </a:pPr>
+              </a:p>
+            </p:txBody>
+          </p:sp>
+          <p:sp>
+            <p:nvSpPr>
+              <p:cNvPr id="214" name="Line"/>
+              <p:cNvSpPr/>
+              <p:nvPr/>
+            </p:nvSpPr>
+            <p:spPr>
+              <a:xfrm flipH="1">
+                <a:off x="9898302" y="2649046"/>
+                <a:ext cx="307084" cy="267366"/>
+              </a:xfrm>
+              <a:prstGeom prst="line">
+                <a:avLst/>
+              </a:prstGeom>
+              <a:noFill/>
+              <a:ln w="63500" cap="flat">
+                <a:solidFill>
+                  <a:srgbClr val="0433FF"/>
+                </a:solidFill>
+                <a:prstDash val="solid"/>
+                <a:miter lim="400000"/>
+              </a:ln>
+              <a:effectLst/>
+            </p:spPr>
+            <p:txBody>
+              <a:bodyPr wrap="square" lIns="50800" tIns="50800" rIns="50800" bIns="50800" numCol="1" anchor="ctr">
+                <a:noAutofit/>
+              </a:bodyPr>
+              <a:lstStyle/>
+              <a:p>
+                <a:pPr algn="l">
+                  <a:lnSpc>
+                    <a:spcPct val="90000"/>
+                  </a:lnSpc>
+                  <a:spcBef>
+                    <a:spcPts val="4500"/>
+                  </a:spcBef>
+                  <a:defRPr sz="4800">
+                    <a:solidFill>
+                      <a:srgbClr val="000000"/>
+                    </a:solidFill>
+                  </a:defRPr>
+                </a:pPr>
+              </a:p>
+            </p:txBody>
+          </p:sp>
+          <p:sp>
+            <p:nvSpPr>
+              <p:cNvPr id="215" name="Line"/>
+              <p:cNvSpPr/>
+              <p:nvPr/>
+            </p:nvSpPr>
+            <p:spPr>
+              <a:xfrm flipH="1">
+                <a:off x="8933674" y="1882352"/>
+                <a:ext cx="77639" cy="400046"/>
+              </a:xfrm>
+              <a:prstGeom prst="line">
+                <a:avLst/>
+              </a:prstGeom>
+              <a:noFill/>
+              <a:ln w="63500" cap="flat">
+                <a:solidFill>
+                  <a:srgbClr val="0433FF"/>
+                </a:solidFill>
+                <a:prstDash val="solid"/>
+                <a:miter lim="400000"/>
+              </a:ln>
+              <a:effectLst/>
+            </p:spPr>
+            <p:txBody>
+              <a:bodyPr wrap="square" lIns="50800" tIns="50800" rIns="50800" bIns="50800" numCol="1" anchor="ctr">
+                <a:noAutofit/>
+              </a:bodyPr>
+              <a:lstStyle/>
+              <a:p>
+                <a:pPr algn="l">
+                  <a:lnSpc>
+                    <a:spcPct val="90000"/>
+                  </a:lnSpc>
+                  <a:spcBef>
+                    <a:spcPts val="4500"/>
+                  </a:spcBef>
+                  <a:defRPr sz="4800">
+                    <a:solidFill>
+                      <a:srgbClr val="000000"/>
+                    </a:solidFill>
+                  </a:defRPr>
+                </a:pPr>
+              </a:p>
+            </p:txBody>
+          </p:sp>
+        </p:grpSp>
         <p:sp>
           <p:nvSpPr>
-            <p:cNvPr id="198" name="Bumpers"/>
+            <p:cNvPr id="217" name="Triangle"/>
             <p:cNvSpPr/>
             <p:nvPr/>
           </p:nvSpPr>
           <p:spPr>
-            <a:xfrm rot="21600000">
-              <a:off x="0" y="-1"/>
-              <a:ext cx="12422786" cy="8468254"/>
+            <a:xfrm rot="8756139">
+              <a:off x="8864389" y="5521462"/>
+              <a:ext cx="2535354" cy="1268252"/>
             </a:xfrm>
             <a:custGeom>
               <a:avLst/>
@@ -9602,307 +10705,30 @@
               </a:cxnLst>
               <a:rect l="0" t="0" r="r" b="b"/>
               <a:pathLst>
-                <a:path w="21486" h="21591" fill="norm" stroke="1" extrusionOk="0">
+                <a:path w="21600" h="21600" fill="norm" stroke="1" extrusionOk="0">
                   <a:moveTo>
-                    <a:pt x="14355" y="1"/>
+                    <a:pt x="0" y="0"/>
                   </a:moveTo>
-                  <a:cubicBezTo>
-                    <a:pt x="14184" y="3"/>
-                    <a:pt x="14013" y="11"/>
-                    <a:pt x="13843" y="26"/>
-                  </a:cubicBezTo>
-                  <a:cubicBezTo>
-                    <a:pt x="13835" y="30"/>
-                    <a:pt x="13826" y="34"/>
-                    <a:pt x="13818" y="38"/>
-                  </a:cubicBezTo>
-                  <a:cubicBezTo>
-                    <a:pt x="13810" y="41"/>
-                    <a:pt x="13802" y="46"/>
-                    <a:pt x="13793" y="49"/>
-                  </a:cubicBezTo>
                   <a:lnTo>
-                    <a:pt x="13792" y="32"/>
+                    <a:pt x="10800" y="21600"/>
                   </a:lnTo>
                   <a:lnTo>
-                    <a:pt x="7548" y="539"/>
-                  </a:lnTo>
-                  <a:cubicBezTo>
-                    <a:pt x="6643" y="569"/>
-                    <a:pt x="5744" y="784"/>
-                    <a:pt x="4872" y="1174"/>
-                  </a:cubicBezTo>
-                  <a:cubicBezTo>
-                    <a:pt x="3433" y="1816"/>
-                    <a:pt x="2050" y="2938"/>
-                    <a:pt x="1143" y="4895"/>
-                  </a:cubicBezTo>
-                  <a:cubicBezTo>
-                    <a:pt x="94" y="7158"/>
-                    <a:pt x="-113" y="10020"/>
-                    <a:pt x="50" y="12758"/>
-                  </a:cubicBezTo>
-                  <a:cubicBezTo>
-                    <a:pt x="129" y="14081"/>
-                    <a:pt x="295" y="15418"/>
-                    <a:pt x="650" y="16641"/>
-                  </a:cubicBezTo>
-                  <a:cubicBezTo>
-                    <a:pt x="969" y="17743"/>
-                    <a:pt x="1437" y="18729"/>
-                    <a:pt x="2030" y="19522"/>
-                  </a:cubicBezTo>
-                  <a:cubicBezTo>
-                    <a:pt x="2668" y="20376"/>
-                    <a:pt x="3375" y="20932"/>
-                    <a:pt x="4119" y="21234"/>
-                  </a:cubicBezTo>
-                  <a:cubicBezTo>
-                    <a:pt x="4856" y="21534"/>
-                    <a:pt x="5617" y="21582"/>
-                    <a:pt x="6345" y="21591"/>
-                  </a:cubicBezTo>
-                  <a:cubicBezTo>
-                    <a:pt x="7075" y="21599"/>
-                    <a:pt x="7808" y="21561"/>
-                    <a:pt x="8544" y="21466"/>
-                  </a:cubicBezTo>
-                  <a:lnTo>
-                    <a:pt x="14566" y="21002"/>
+                    <a:pt x="21600" y="0"/>
                   </a:lnTo>
                   <a:lnTo>
-                    <a:pt x="14566" y="21002"/>
+                    <a:pt x="0" y="0"/>
                   </a:lnTo>
-                  <a:cubicBezTo>
-                    <a:pt x="14676" y="21007"/>
-                    <a:pt x="14786" y="20988"/>
-                    <a:pt x="14896" y="20966"/>
-                  </a:cubicBezTo>
-                  <a:cubicBezTo>
-                    <a:pt x="15005" y="20944"/>
-                    <a:pt x="15114" y="20919"/>
-                    <a:pt x="15224" y="20894"/>
-                  </a:cubicBezTo>
-                  <a:cubicBezTo>
-                    <a:pt x="16033" y="20716"/>
-                    <a:pt x="16838" y="20385"/>
-                    <a:pt x="17608" y="19879"/>
-                  </a:cubicBezTo>
-                  <a:cubicBezTo>
-                    <a:pt x="18367" y="19381"/>
-                    <a:pt x="19101" y="18707"/>
-                    <a:pt x="19717" y="17744"/>
-                  </a:cubicBezTo>
-                  <a:cubicBezTo>
-                    <a:pt x="20970" y="15786"/>
-                    <a:pt x="21485" y="13153"/>
-                    <a:pt x="21486" y="10553"/>
-                  </a:cubicBezTo>
-                  <a:cubicBezTo>
-                    <a:pt x="21487" y="7871"/>
-                    <a:pt x="20944" y="5084"/>
-                    <a:pt x="19644" y="3018"/>
-                  </a:cubicBezTo>
-                  <a:cubicBezTo>
-                    <a:pt x="18371" y="996"/>
-                    <a:pt x="16615" y="141"/>
-                    <a:pt x="14866" y="16"/>
-                  </a:cubicBezTo>
-                  <a:cubicBezTo>
-                    <a:pt x="14696" y="4"/>
-                    <a:pt x="14525" y="-1"/>
-                    <a:pt x="14355" y="1"/>
-                  </a:cubicBezTo>
-                  <a:close/>
-                </a:path>
-              </a:pathLst>
-            </a:custGeom>
-            <a:noFill/>
-            <a:ln w="63500" cap="flat">
-              <a:solidFill>
-                <a:srgbClr val="000000"/>
-              </a:solidFill>
-              <a:prstDash val="solid"/>
-              <a:miter lim="400000"/>
-            </a:ln>
-            <a:effectLst/>
-            <a:extLst>
-              <a:ext uri="{C572A759-6A51-4108-AA02-DFA0A04FC94B}">
-                <ma14:wrappingTextBoxFlag xmlns:ma14="http://schemas.microsoft.com/office/mac/drawingml/2011/main" val="1"/>
-              </a:ext>
-            </a:extLst>
-          </p:spPr>
-          <p:txBody>
-            <a:bodyPr wrap="square" lIns="50800" tIns="50800" rIns="50800" bIns="50800" numCol="1" anchor="ctr">
-              <a:noAutofit/>
-            </a:bodyPr>
-            <a:lstStyle>
-              <a:lvl1pPr defTabSz="825500">
-                <a:defRPr sz="3200">
-                  <a:solidFill>
-                    <a:srgbClr val="FFFFFF"/>
-                  </a:solidFill>
-                  <a:latin typeface="Helvetica Neue Medium"/>
-                  <a:ea typeface="Helvetica Neue Medium"/>
-                  <a:cs typeface="Helvetica Neue Medium"/>
-                  <a:sym typeface="Helvetica Neue Medium"/>
-                </a:defRPr>
-              </a:lvl1pPr>
-            </a:lstStyle>
-            <a:p>
-              <a:pPr/>
-              <a:r>
-                <a:t>]\</a:t>
-              </a:r>
-            </a:p>
-          </p:txBody>
-        </p:sp>
-        <p:sp>
-          <p:nvSpPr>
-            <p:cNvPr id="199" name="Outside Boundary"/>
-            <p:cNvSpPr/>
-            <p:nvPr/>
-          </p:nvSpPr>
-          <p:spPr>
-            <a:xfrm rot="21600000">
-              <a:off x="1162107" y="1076156"/>
-              <a:ext cx="10098571" cy="6315940"/>
-            </a:xfrm>
-            <a:custGeom>
-              <a:avLst/>
-              <a:gdLst/>
-              <a:ahLst/>
-              <a:cxnLst>
-                <a:cxn ang="0">
-                  <a:pos x="wd2" y="hd2"/>
-                </a:cxn>
-                <a:cxn ang="5400000">
-                  <a:pos x="wd2" y="hd2"/>
-                </a:cxn>
-                <a:cxn ang="10800000">
-                  <a:pos x="wd2" y="hd2"/>
-                </a:cxn>
-                <a:cxn ang="16200000">
-                  <a:pos x="wd2" y="hd2"/>
-                </a:cxn>
-              </a:cxnLst>
-              <a:rect l="0" t="0" r="r" b="b"/>
-              <a:pathLst>
-                <a:path w="21482" h="21591" fill="norm" stroke="1" extrusionOk="0">
-                  <a:moveTo>
-                    <a:pt x="14352" y="1"/>
-                  </a:moveTo>
-                  <a:cubicBezTo>
-                    <a:pt x="14182" y="3"/>
-                    <a:pt x="14011" y="11"/>
-                    <a:pt x="13841" y="26"/>
-                  </a:cubicBezTo>
-                  <a:cubicBezTo>
-                    <a:pt x="13824" y="33"/>
-                    <a:pt x="13808" y="42"/>
-                    <a:pt x="13791" y="49"/>
-                  </a:cubicBezTo>
-                  <a:lnTo>
-                    <a:pt x="13790" y="32"/>
-                  </a:lnTo>
-                  <a:lnTo>
-                    <a:pt x="7547" y="538"/>
-                  </a:lnTo>
-                  <a:cubicBezTo>
-                    <a:pt x="6642" y="569"/>
-                    <a:pt x="5743" y="784"/>
-                    <a:pt x="4871" y="1173"/>
-                  </a:cubicBezTo>
-                  <a:cubicBezTo>
-                    <a:pt x="3432" y="1816"/>
-                    <a:pt x="2050" y="2937"/>
-                    <a:pt x="1143" y="4895"/>
-                  </a:cubicBezTo>
-                  <a:cubicBezTo>
-                    <a:pt x="94" y="7158"/>
-                    <a:pt x="-113" y="10020"/>
-                    <a:pt x="50" y="12758"/>
-                  </a:cubicBezTo>
-                  <a:cubicBezTo>
-                    <a:pt x="129" y="14081"/>
-                    <a:pt x="295" y="15418"/>
-                    <a:pt x="650" y="16641"/>
-                  </a:cubicBezTo>
-                  <a:cubicBezTo>
-                    <a:pt x="969" y="17743"/>
-                    <a:pt x="1437" y="18729"/>
-                    <a:pt x="2029" y="19522"/>
-                  </a:cubicBezTo>
-                  <a:cubicBezTo>
-                    <a:pt x="2667" y="20376"/>
-                    <a:pt x="3374" y="20932"/>
-                    <a:pt x="4118" y="21234"/>
-                  </a:cubicBezTo>
-                  <a:cubicBezTo>
-                    <a:pt x="4855" y="21534"/>
-                    <a:pt x="5616" y="21582"/>
-                    <a:pt x="6344" y="21591"/>
-                  </a:cubicBezTo>
-                  <a:cubicBezTo>
-                    <a:pt x="7074" y="21599"/>
-                    <a:pt x="7807" y="21561"/>
-                    <a:pt x="8543" y="21466"/>
-                  </a:cubicBezTo>
-                  <a:lnTo>
-                    <a:pt x="14563" y="21002"/>
-                  </a:lnTo>
-                  <a:cubicBezTo>
-                    <a:pt x="14563" y="21002"/>
-                    <a:pt x="14564" y="21002"/>
-                    <a:pt x="14564" y="21002"/>
-                  </a:cubicBezTo>
-                  <a:cubicBezTo>
-                    <a:pt x="14789" y="21013"/>
-                    <a:pt x="15015" y="21000"/>
-                    <a:pt x="15241" y="20966"/>
-                  </a:cubicBezTo>
-                  <a:cubicBezTo>
-                    <a:pt x="16054" y="20843"/>
-                    <a:pt x="16844" y="20420"/>
-                    <a:pt x="17605" y="19879"/>
-                  </a:cubicBezTo>
-                  <a:cubicBezTo>
-                    <a:pt x="18351" y="19349"/>
-                    <a:pt x="19091" y="18698"/>
-                    <a:pt x="19714" y="17744"/>
-                  </a:cubicBezTo>
-                  <a:cubicBezTo>
-                    <a:pt x="20982" y="15803"/>
-                    <a:pt x="21487" y="13156"/>
-                    <a:pt x="21483" y="10553"/>
-                  </a:cubicBezTo>
-                  <a:cubicBezTo>
-                    <a:pt x="21478" y="7873"/>
-                    <a:pt x="20939" y="5084"/>
-                    <a:pt x="19640" y="3018"/>
-                  </a:cubicBezTo>
-                  <a:cubicBezTo>
-                    <a:pt x="18369" y="994"/>
-                    <a:pt x="16612" y="141"/>
-                    <a:pt x="14863" y="16"/>
-                  </a:cubicBezTo>
-                  <a:cubicBezTo>
-                    <a:pt x="14693" y="4"/>
-                    <a:pt x="14523" y="-1"/>
-                    <a:pt x="14352" y="1"/>
-                  </a:cubicBezTo>
                   <a:close/>
                 </a:path>
               </a:pathLst>
             </a:custGeom>
             <a:solidFill>
-              <a:srgbClr val="FFFFFF"/>
+              <a:srgbClr val="009051">
+                <a:alpha val="51345"/>
+              </a:srgbClr>
             </a:solidFill>
-            <a:ln w="63500" cap="flat">
-              <a:solidFill>
-                <a:srgbClr val="0433FF"/>
-              </a:solidFill>
-              <a:prstDash val="solid"/>
+            <a:ln w="12700" cap="flat">
+              <a:noFill/>
               <a:miter lim="400000"/>
             </a:ln>
             <a:effectLst/>
@@ -9929,28 +10755,199 @@
         </p:sp>
         <p:sp>
           <p:nvSpPr>
-            <p:cNvPr id="200" name="Inside Boundary"/>
+            <p:cNvPr id="218" name="Line"/>
             <p:cNvSpPr/>
             <p:nvPr/>
           </p:nvSpPr>
           <p:spPr>
-            <a:xfrm rot="21600000">
-              <a:off x="2739738" y="2796994"/>
-              <a:ext cx="6907716" cy="2865268"/>
+            <a:xfrm rot="18496556">
+              <a:off x="1651203" y="2576918"/>
+              <a:ext cx="4471770" cy="862974"/>
             </a:xfrm>
-            <a:prstGeom prst="roundRect">
-              <a:avLst>
-                <a:gd name="adj" fmla="val 48362"/>
-              </a:avLst>
+            <a:custGeom>
+              <a:avLst/>
+              <a:gdLst/>
+              <a:ahLst/>
+              <a:cxnLst>
+                <a:cxn ang="0">
+                  <a:pos x="wd2" y="hd2"/>
+                </a:cxn>
+                <a:cxn ang="5400000">
+                  <a:pos x="wd2" y="hd2"/>
+                </a:cxn>
+                <a:cxn ang="10800000">
+                  <a:pos x="wd2" y="hd2"/>
+                </a:cxn>
+                <a:cxn ang="16200000">
+                  <a:pos x="wd2" y="hd2"/>
+                </a:cxn>
+              </a:cxnLst>
+              <a:rect l="0" t="0" r="r" b="b"/>
+              <a:pathLst>
+                <a:path w="21600" h="20701" fill="norm" stroke="1" extrusionOk="0">
+                  <a:moveTo>
+                    <a:pt x="0" y="20701"/>
+                  </a:moveTo>
+                  <a:cubicBezTo>
+                    <a:pt x="2097" y="16024"/>
+                    <a:pt x="4259" y="12111"/>
+                    <a:pt x="6470" y="8992"/>
+                  </a:cubicBezTo>
+                  <a:cubicBezTo>
+                    <a:pt x="11386" y="2057"/>
+                    <a:pt x="16495" y="-899"/>
+                    <a:pt x="21600" y="237"/>
+                  </a:cubicBezTo>
+                </a:path>
+              </a:pathLst>
+            </a:custGeom>
+            <a:noFill/>
+            <a:ln w="63500" cap="flat">
+              <a:solidFill>
+                <a:srgbClr val="FF2600"/>
+              </a:solidFill>
+              <a:prstDash val="solid"/>
+              <a:miter lim="400000"/>
+              <a:tailEnd type="triangle" w="med" len="med"/>
+            </a:ln>
+            <a:effectLst/>
+          </p:spPr>
+          <p:txBody>
+            <a:bodyPr wrap="square" lIns="50800" tIns="50800" rIns="50800" bIns="50800" numCol="1" anchor="ctr">
+              <a:noAutofit/>
+            </a:bodyPr>
+            <a:lstStyle/>
+            <a:p>
+              <a:pPr/>
+            </a:p>
+          </p:txBody>
+        </p:sp>
+        <p:sp>
+          <p:nvSpPr>
+            <p:cNvPr id="219" name="Line"/>
+            <p:cNvSpPr/>
+            <p:nvPr/>
+          </p:nvSpPr>
+          <p:spPr>
+            <a:xfrm flipV="1">
+              <a:off x="9760012" y="3298510"/>
+              <a:ext cx="1881248" cy="2396354"/>
+            </a:xfrm>
+            <a:prstGeom prst="line">
+              <a:avLst/>
+            </a:prstGeom>
+            <a:noFill/>
+            <a:ln w="63500" cap="flat">
+              <a:solidFill>
+                <a:schemeClr val="accent4">
+                  <a:hueOff val="-858837"/>
+                  <a:lumOff val="-9791"/>
+                </a:schemeClr>
+              </a:solidFill>
+              <a:prstDash val="solid"/>
+              <a:miter lim="400000"/>
+              <a:tailEnd type="triangle" w="med" len="med"/>
+            </a:ln>
+            <a:effectLst/>
+          </p:spPr>
+          <p:txBody>
+            <a:bodyPr wrap="square" lIns="50800" tIns="50800" rIns="50800" bIns="50800" numCol="1" anchor="ctr">
+              <a:noAutofit/>
+            </a:bodyPr>
+            <a:lstStyle/>
+            <a:p>
+              <a:pPr/>
+            </a:p>
+          </p:txBody>
+        </p:sp>
+        <p:sp>
+          <p:nvSpPr>
+            <p:cNvPr id="220" name="Line"/>
+            <p:cNvSpPr/>
+            <p:nvPr/>
+          </p:nvSpPr>
+          <p:spPr>
+            <a:xfrm rot="16863997">
+              <a:off x="7195720" y="2329150"/>
+              <a:ext cx="4560007" cy="1954342"/>
+            </a:xfrm>
+            <a:custGeom>
+              <a:avLst/>
+              <a:gdLst/>
+              <a:ahLst/>
+              <a:cxnLst>
+                <a:cxn ang="0">
+                  <a:pos x="wd2" y="hd2"/>
+                </a:cxn>
+                <a:cxn ang="5400000">
+                  <a:pos x="wd2" y="hd2"/>
+                </a:cxn>
+                <a:cxn ang="10800000">
+                  <a:pos x="wd2" y="hd2"/>
+                </a:cxn>
+                <a:cxn ang="16200000">
+                  <a:pos x="wd2" y="hd2"/>
+                </a:cxn>
+              </a:cxnLst>
+              <a:rect l="0" t="0" r="r" b="b"/>
+              <a:pathLst>
+                <a:path w="21600" h="20897" fill="norm" stroke="1" extrusionOk="0">
+                  <a:moveTo>
+                    <a:pt x="0" y="18787"/>
+                  </a:moveTo>
+                  <a:cubicBezTo>
+                    <a:pt x="3636" y="21529"/>
+                    <a:pt x="7565" y="21600"/>
+                    <a:pt x="11220" y="18990"/>
+                  </a:cubicBezTo>
+                  <a:cubicBezTo>
+                    <a:pt x="15621" y="15847"/>
+                    <a:pt x="19330" y="9062"/>
+                    <a:pt x="21600" y="0"/>
+                  </a:cubicBezTo>
+                </a:path>
+              </a:pathLst>
+            </a:custGeom>
+            <a:noFill/>
+            <a:ln w="63500" cap="flat">
+              <a:solidFill>
+                <a:srgbClr val="FF2600"/>
+              </a:solidFill>
+              <a:prstDash val="solid"/>
+              <a:miter lim="400000"/>
+              <a:tailEnd type="triangle" w="med" len="med"/>
+            </a:ln>
+            <a:effectLst/>
+          </p:spPr>
+          <p:txBody>
+            <a:bodyPr wrap="square" lIns="50800" tIns="50800" rIns="50800" bIns="50800" numCol="1" anchor="ctr">
+              <a:noAutofit/>
+            </a:bodyPr>
+            <a:lstStyle/>
+            <a:p>
+              <a:pPr/>
+            </a:p>
+          </p:txBody>
+        </p:sp>
+        <p:sp>
+          <p:nvSpPr>
+            <p:cNvPr id="221" name="Circle"/>
+            <p:cNvSpPr/>
+            <p:nvPr/>
+          </p:nvSpPr>
+          <p:spPr>
+            <a:xfrm rot="16200000">
+              <a:off x="9687076" y="5568824"/>
+              <a:ext cx="243141" cy="242846"/>
+            </a:xfrm>
+            <a:prstGeom prst="ellipse">
+              <a:avLst/>
             </a:prstGeom>
             <a:solidFill>
-              <a:srgbClr val="D6D6D6"/>
+              <a:srgbClr val="000000"/>
             </a:solidFill>
-            <a:ln w="63500" cap="flat">
-              <a:solidFill>
-                <a:srgbClr val="0433FF"/>
-              </a:solidFill>
-              <a:prstDash val="solid"/>
+            <a:ln w="12700" cap="flat">
+              <a:noFill/>
               <a:miter lim="400000"/>
             </a:ln>
             <a:effectLst/>
@@ -9977,24 +10974,59 @@
         </p:sp>
         <p:sp>
           <p:nvSpPr>
-            <p:cNvPr id="201" name="Pivot Line"/>
+            <p:cNvPr id="222" name="Triangle"/>
             <p:cNvSpPr/>
             <p:nvPr/>
           </p:nvSpPr>
           <p:spPr>
-            <a:xfrm flipV="1">
-              <a:off x="4214645" y="1254811"/>
-              <a:ext cx="1" cy="1544175"/>
+            <a:xfrm rot="10783748">
+              <a:off x="7199826" y="6507382"/>
+              <a:ext cx="2016095" cy="1023503"/>
             </a:xfrm>
-            <a:prstGeom prst="line">
+            <a:custGeom>
               <a:avLst/>
-            </a:prstGeom>
-            <a:noFill/>
-            <a:ln w="63500" cap="flat">
-              <a:solidFill>
-                <a:srgbClr val="0433FF"/>
-              </a:solidFill>
-              <a:prstDash val="solid"/>
+              <a:gdLst/>
+              <a:ahLst/>
+              <a:cxnLst>
+                <a:cxn ang="0">
+                  <a:pos x="wd2" y="hd2"/>
+                </a:cxn>
+                <a:cxn ang="5400000">
+                  <a:pos x="wd2" y="hd2"/>
+                </a:cxn>
+                <a:cxn ang="10800000">
+                  <a:pos x="wd2" y="hd2"/>
+                </a:cxn>
+                <a:cxn ang="16200000">
+                  <a:pos x="wd2" y="hd2"/>
+                </a:cxn>
+              </a:cxnLst>
+              <a:rect l="0" t="0" r="r" b="b"/>
+              <a:pathLst>
+                <a:path w="21600" h="21600" fill="norm" stroke="1" extrusionOk="0">
+                  <a:moveTo>
+                    <a:pt x="0" y="0"/>
+                  </a:moveTo>
+                  <a:lnTo>
+                    <a:pt x="10800" y="21600"/>
+                  </a:lnTo>
+                  <a:lnTo>
+                    <a:pt x="21600" y="0"/>
+                  </a:lnTo>
+                  <a:lnTo>
+                    <a:pt x="0" y="0"/>
+                  </a:lnTo>
+                  <a:close/>
+                </a:path>
+              </a:pathLst>
+            </a:custGeom>
+            <a:solidFill>
+              <a:srgbClr val="009051">
+                <a:alpha val="51345"/>
+              </a:srgbClr>
+            </a:solidFill>
+            <a:ln w="12700" cap="flat">
+              <a:noFill/>
               <a:miter lim="400000"/>
             </a:ln>
             <a:effectLst/>
@@ -10005,17 +11037,15 @@
             </a:bodyPr>
             <a:lstStyle/>
             <a:p>
-              <a:pPr algn="l">
-                <a:lnSpc>
-                  <a:spcPct val="90000"/>
-                </a:lnSpc>
-                <a:spcBef>
-                  <a:spcPts val="4500"/>
-                </a:spcBef>
-                <a:defRPr sz="4800">
+              <a:pPr defTabSz="825500">
+                <a:defRPr sz="3200">
                   <a:solidFill>
-                    <a:srgbClr val="000000"/>
+                    <a:srgbClr val="FFFFFF"/>
                   </a:solidFill>
+                  <a:latin typeface="Helvetica Neue Medium"/>
+                  <a:ea typeface="Helvetica Neue Medium"/>
+                  <a:cs typeface="Helvetica Neue Medium"/>
+                  <a:sym typeface="Helvetica Neue Medium"/>
                 </a:defRPr>
               </a:pPr>
             </a:p>
@@ -10023,24 +11053,202 @@
         </p:sp>
         <p:sp>
           <p:nvSpPr>
-            <p:cNvPr id="202" name="Jammer Line"/>
+            <p:cNvPr id="223" name="Line"/>
             <p:cNvSpPr/>
             <p:nvPr/>
           </p:nvSpPr>
           <p:spPr>
-            <a:xfrm flipV="1">
-              <a:off x="7646141" y="1077941"/>
-              <a:ext cx="1" cy="1698481"/>
+            <a:xfrm rot="16398358">
+              <a:off x="5554018" y="3006363"/>
+              <a:ext cx="5637645" cy="1417070"/>
             </a:xfrm>
-            <a:prstGeom prst="line">
+            <a:custGeom>
               <a:avLst/>
-            </a:prstGeom>
+              <a:gdLst/>
+              <a:ahLst/>
+              <a:cxnLst>
+                <a:cxn ang="0">
+                  <a:pos x="wd2" y="hd2"/>
+                </a:cxn>
+                <a:cxn ang="5400000">
+                  <a:pos x="wd2" y="hd2"/>
+                </a:cxn>
+                <a:cxn ang="10800000">
+                  <a:pos x="wd2" y="hd2"/>
+                </a:cxn>
+                <a:cxn ang="16200000">
+                  <a:pos x="wd2" y="hd2"/>
+                </a:cxn>
+              </a:cxnLst>
+              <a:rect l="0" t="0" r="r" b="b"/>
+              <a:pathLst>
+                <a:path w="21600" h="20638" fill="norm" stroke="1" extrusionOk="0">
+                  <a:moveTo>
+                    <a:pt x="0" y="10385"/>
+                  </a:moveTo>
+                  <a:cubicBezTo>
+                    <a:pt x="3136" y="18074"/>
+                    <a:pt x="6855" y="21600"/>
+                    <a:pt x="10575" y="20412"/>
+                  </a:cubicBezTo>
+                  <a:cubicBezTo>
+                    <a:pt x="14792" y="19066"/>
+                    <a:pt x="18724" y="11786"/>
+                    <a:pt x="21600" y="0"/>
+                  </a:cubicBezTo>
+                </a:path>
+              </a:pathLst>
+            </a:custGeom>
             <a:noFill/>
             <a:ln w="63500" cap="flat">
               <a:solidFill>
-                <a:srgbClr val="0433FF"/>
+                <a:srgbClr val="FF2600"/>
               </a:solidFill>
               <a:prstDash val="solid"/>
+              <a:miter lim="400000"/>
+              <a:tailEnd type="triangle" w="med" len="med"/>
+            </a:ln>
+            <a:effectLst/>
+          </p:spPr>
+          <p:txBody>
+            <a:bodyPr wrap="square" lIns="50800" tIns="50800" rIns="50800" bIns="50800" numCol="1" anchor="ctr">
+              <a:noAutofit/>
+            </a:bodyPr>
+            <a:lstStyle/>
+            <a:p>
+              <a:pPr/>
+            </a:p>
+          </p:txBody>
+        </p:sp>
+        <p:sp>
+          <p:nvSpPr>
+            <p:cNvPr id="224" name="Line"/>
+            <p:cNvSpPr/>
+            <p:nvPr/>
+          </p:nvSpPr>
+          <p:spPr>
+            <a:xfrm rot="10516140">
+              <a:off x="2648831" y="6784532"/>
+              <a:ext cx="5636283" cy="592712"/>
+            </a:xfrm>
+            <a:custGeom>
+              <a:avLst/>
+              <a:gdLst/>
+              <a:ahLst/>
+              <a:cxnLst>
+                <a:cxn ang="0">
+                  <a:pos x="wd2" y="hd2"/>
+                </a:cxn>
+                <a:cxn ang="5400000">
+                  <a:pos x="wd2" y="hd2"/>
+                </a:cxn>
+                <a:cxn ang="10800000">
+                  <a:pos x="wd2" y="hd2"/>
+                </a:cxn>
+                <a:cxn ang="16200000">
+                  <a:pos x="wd2" y="hd2"/>
+                </a:cxn>
+              </a:cxnLst>
+              <a:rect l="0" t="0" r="r" b="b"/>
+              <a:pathLst>
+                <a:path w="21600" h="21600" fill="norm" stroke="1" extrusionOk="0">
+                  <a:moveTo>
+                    <a:pt x="0" y="21600"/>
+                  </a:moveTo>
+                  <a:cubicBezTo>
+                    <a:pt x="3226" y="18731"/>
+                    <a:pt x="6459" y="16514"/>
+                    <a:pt x="9695" y="14949"/>
+                  </a:cubicBezTo>
+                  <a:cubicBezTo>
+                    <a:pt x="11840" y="13913"/>
+                    <a:pt x="13988" y="13161"/>
+                    <a:pt x="16119" y="10621"/>
+                  </a:cubicBezTo>
+                  <a:cubicBezTo>
+                    <a:pt x="17972" y="8414"/>
+                    <a:pt x="19804" y="4863"/>
+                    <a:pt x="21600" y="0"/>
+                  </a:cubicBezTo>
+                </a:path>
+              </a:pathLst>
+            </a:custGeom>
+            <a:noFill/>
+            <a:ln w="63500" cap="flat">
+              <a:solidFill>
+                <a:srgbClr val="FF2600"/>
+              </a:solidFill>
+              <a:prstDash val="solid"/>
+              <a:miter lim="400000"/>
+              <a:tailEnd type="triangle" w="med" len="med"/>
+            </a:ln>
+            <a:effectLst/>
+          </p:spPr>
+          <p:txBody>
+            <a:bodyPr wrap="square" lIns="50800" tIns="50800" rIns="50800" bIns="50800" numCol="1" anchor="ctr">
+              <a:noAutofit/>
+            </a:bodyPr>
+            <a:lstStyle/>
+            <a:p>
+              <a:pPr/>
+            </a:p>
+          </p:txBody>
+        </p:sp>
+        <p:sp>
+          <p:nvSpPr>
+            <p:cNvPr id="225" name="Triangle"/>
+            <p:cNvSpPr/>
+            <p:nvPr/>
+          </p:nvSpPr>
+          <p:spPr>
+            <a:xfrm rot="15176208">
+              <a:off x="1285740" y="4695252"/>
+              <a:ext cx="2087165" cy="1104659"/>
+            </a:xfrm>
+            <a:custGeom>
+              <a:avLst/>
+              <a:gdLst/>
+              <a:ahLst/>
+              <a:cxnLst>
+                <a:cxn ang="0">
+                  <a:pos x="wd2" y="hd2"/>
+                </a:cxn>
+                <a:cxn ang="5400000">
+                  <a:pos x="wd2" y="hd2"/>
+                </a:cxn>
+                <a:cxn ang="10800000">
+                  <a:pos x="wd2" y="hd2"/>
+                </a:cxn>
+                <a:cxn ang="16200000">
+                  <a:pos x="wd2" y="hd2"/>
+                </a:cxn>
+              </a:cxnLst>
+              <a:rect l="0" t="0" r="r" b="b"/>
+              <a:pathLst>
+                <a:path w="21600" h="21600" fill="norm" stroke="1" extrusionOk="0">
+                  <a:moveTo>
+                    <a:pt x="0" y="0"/>
+                  </a:moveTo>
+                  <a:lnTo>
+                    <a:pt x="10800" y="21600"/>
+                  </a:lnTo>
+                  <a:lnTo>
+                    <a:pt x="21600" y="0"/>
+                  </a:lnTo>
+                  <a:lnTo>
+                    <a:pt x="0" y="0"/>
+                  </a:lnTo>
+                  <a:close/>
+                </a:path>
+              </a:pathLst>
+            </a:custGeom>
+            <a:solidFill>
+              <a:srgbClr val="009051">
+                <a:alpha val="51345"/>
+              </a:srgbClr>
+            </a:solidFill>
+            <a:ln w="12700" cap="flat">
+              <a:noFill/>
               <a:miter lim="400000"/>
             </a:ln>
             <a:effectLst/>
@@ -10051,17 +11259,15 @@
             </a:bodyPr>
             <a:lstStyle/>
             <a:p>
-              <a:pPr algn="l">
-                <a:lnSpc>
-                  <a:spcPct val="90000"/>
-                </a:lnSpc>
-                <a:spcBef>
-                  <a:spcPts val="4500"/>
-                </a:spcBef>
-                <a:defRPr sz="4800">
+              <a:pPr defTabSz="825500">
+                <a:defRPr sz="3200">
                   <a:solidFill>
-                    <a:srgbClr val="000000"/>
+                    <a:srgbClr val="FFFFFF"/>
                   </a:solidFill>
+                  <a:latin typeface="Helvetica Neue Medium"/>
+                  <a:ea typeface="Helvetica Neue Medium"/>
+                  <a:cs typeface="Helvetica Neue Medium"/>
+                  <a:sym typeface="Helvetica Neue Medium"/>
                 </a:defRPr>
               </a:pPr>
             </a:p>
@@ -10069,24 +11275,92 @@
         </p:sp>
         <p:sp>
           <p:nvSpPr>
-            <p:cNvPr id="203" name="Line"/>
+            <p:cNvPr id="226" name="Line"/>
             <p:cNvSpPr/>
             <p:nvPr/>
           </p:nvSpPr>
           <p:spPr>
-            <a:xfrm flipH="1" flipV="1">
-              <a:off x="2932039" y="2251406"/>
-              <a:ext cx="232981" cy="326890"/>
+            <a:xfrm rot="16185042">
+              <a:off x="995173" y="2713267"/>
+              <a:ext cx="3904029" cy="731151"/>
             </a:xfrm>
-            <a:prstGeom prst="line">
+            <a:custGeom>
               <a:avLst/>
-            </a:prstGeom>
+              <a:gdLst/>
+              <a:ahLst/>
+              <a:cxnLst>
+                <a:cxn ang="0">
+                  <a:pos x="wd2" y="hd2"/>
+                </a:cxn>
+                <a:cxn ang="5400000">
+                  <a:pos x="wd2" y="hd2"/>
+                </a:cxn>
+                <a:cxn ang="10800000">
+                  <a:pos x="wd2" y="hd2"/>
+                </a:cxn>
+                <a:cxn ang="16200000">
+                  <a:pos x="wd2" y="hd2"/>
+                </a:cxn>
+              </a:cxnLst>
+              <a:rect l="0" t="0" r="r" b="b"/>
+              <a:pathLst>
+                <a:path w="21600" h="19741" fill="norm" stroke="1" extrusionOk="0">
+                  <a:moveTo>
+                    <a:pt x="0" y="6760"/>
+                  </a:moveTo>
+                  <a:cubicBezTo>
+                    <a:pt x="4112" y="-287"/>
+                    <a:pt x="8535" y="-1859"/>
+                    <a:pt x="12812" y="2205"/>
+                  </a:cubicBezTo>
+                  <a:cubicBezTo>
+                    <a:pt x="15949" y="5185"/>
+                    <a:pt x="18935" y="11143"/>
+                    <a:pt x="21600" y="19741"/>
+                  </a:cubicBezTo>
+                </a:path>
+              </a:pathLst>
+            </a:custGeom>
             <a:noFill/>
             <a:ln w="63500" cap="flat">
               <a:solidFill>
-                <a:srgbClr val="0433FF"/>
+                <a:srgbClr val="FF2600"/>
               </a:solidFill>
               <a:prstDash val="solid"/>
+              <a:miter lim="400000"/>
+              <a:tailEnd type="triangle" w="med" len="med"/>
+            </a:ln>
+            <a:effectLst/>
+          </p:spPr>
+          <p:txBody>
+            <a:bodyPr wrap="square" lIns="50800" tIns="50800" rIns="50800" bIns="50800" numCol="1" anchor="ctr">
+              <a:noAutofit/>
+            </a:bodyPr>
+            <a:lstStyle/>
+            <a:p>
+              <a:pPr/>
+            </a:p>
+          </p:txBody>
+        </p:sp>
+        <p:sp>
+          <p:nvSpPr>
+            <p:cNvPr id="227" name="Circle"/>
+            <p:cNvSpPr/>
+            <p:nvPr/>
+          </p:nvSpPr>
+          <p:spPr>
+            <a:xfrm rot="16200000">
+              <a:off x="2709511" y="4963306"/>
+              <a:ext cx="243140" cy="242845"/>
+            </a:xfrm>
+            <a:prstGeom prst="ellipse">
+              <a:avLst/>
+            </a:prstGeom>
+            <a:solidFill>
+              <a:srgbClr val="000000"/>
+            </a:solidFill>
+            <a:ln w="12700" cap="flat">
+              <a:noFill/>
               <a:miter lim="400000"/>
             </a:ln>
             <a:effectLst/>
@@ -10097,17 +11371,15 @@
             </a:bodyPr>
             <a:lstStyle/>
             <a:p>
-              <a:pPr algn="l">
-                <a:lnSpc>
-                  <a:spcPct val="90000"/>
-                </a:lnSpc>
-                <a:spcBef>
-                  <a:spcPts val="4500"/>
-                </a:spcBef>
-                <a:defRPr sz="4800">
+              <a:pPr defTabSz="825500">
+                <a:defRPr sz="3200">
                   <a:solidFill>
-                    <a:srgbClr val="000000"/>
+                    <a:srgbClr val="FFFFFF"/>
                   </a:solidFill>
+                  <a:latin typeface="Helvetica Neue Medium"/>
+                  <a:ea typeface="Helvetica Neue Medium"/>
+                  <a:cs typeface="Helvetica Neue Medium"/>
+                  <a:sym typeface="Helvetica Neue Medium"/>
                 </a:defRPr>
               </a:pPr>
             </a:p>
@@ -10115,14 +11387,14 @@
         </p:sp>
         <p:sp>
           <p:nvSpPr>
-            <p:cNvPr id="204" name="Line"/>
+            <p:cNvPr id="228" name="Line"/>
             <p:cNvSpPr/>
             <p:nvPr/>
           </p:nvSpPr>
           <p:spPr>
-            <a:xfrm flipH="1" flipV="1">
-              <a:off x="1912208" y="3528669"/>
-              <a:ext cx="362191" cy="172912"/>
+            <a:xfrm>
+              <a:off x="8227136" y="6529535"/>
+              <a:ext cx="2397786" cy="730325"/>
             </a:xfrm>
             <a:prstGeom prst="line">
               <a:avLst/>
@@ -10130,9 +11402,163 @@
             <a:noFill/>
             <a:ln w="63500" cap="flat">
               <a:solidFill>
-                <a:srgbClr val="0433FF"/>
+                <a:schemeClr val="accent4">
+                  <a:hueOff val="-858837"/>
+                  <a:lumOff val="-9791"/>
+                </a:schemeClr>
               </a:solidFill>
               <a:prstDash val="solid"/>
+              <a:miter lim="400000"/>
+              <a:tailEnd type="triangle" w="med" len="med"/>
+            </a:ln>
+            <a:effectLst/>
+          </p:spPr>
+          <p:txBody>
+            <a:bodyPr wrap="square" lIns="50800" tIns="50800" rIns="50800" bIns="50800" numCol="1" anchor="ctr">
+              <a:noAutofit/>
+            </a:bodyPr>
+            <a:lstStyle/>
+            <a:p>
+              <a:pPr/>
+            </a:p>
+          </p:txBody>
+        </p:sp>
+        <p:sp>
+          <p:nvSpPr>
+            <p:cNvPr id="229" name="Line"/>
+            <p:cNvSpPr/>
+            <p:nvPr/>
+          </p:nvSpPr>
+          <p:spPr>
+            <a:xfrm flipH="1" flipV="1">
+              <a:off x="1192647" y="2782009"/>
+              <a:ext cx="1631634" cy="2256976"/>
+            </a:xfrm>
+            <a:prstGeom prst="line">
+              <a:avLst/>
+            </a:prstGeom>
+            <a:noFill/>
+            <a:ln w="63500" cap="flat">
+              <a:solidFill>
+                <a:schemeClr val="accent4">
+                  <a:hueOff val="-858837"/>
+                  <a:lumOff val="-9791"/>
+                </a:schemeClr>
+              </a:solidFill>
+              <a:prstDash val="solid"/>
+              <a:miter lim="400000"/>
+              <a:tailEnd type="triangle" w="med" len="med"/>
+            </a:ln>
+            <a:effectLst/>
+          </p:spPr>
+          <p:txBody>
+            <a:bodyPr wrap="square" lIns="50800" tIns="50800" rIns="50800" bIns="50800" numCol="1" anchor="ctr">
+              <a:noAutofit/>
+            </a:bodyPr>
+            <a:lstStyle/>
+            <a:p>
+              <a:pPr/>
+            </a:p>
+          </p:txBody>
+        </p:sp>
+        <p:sp>
+          <p:nvSpPr>
+            <p:cNvPr id="230" name="Line"/>
+            <p:cNvSpPr/>
+            <p:nvPr/>
+          </p:nvSpPr>
+          <p:spPr>
+            <a:xfrm rot="18496556">
+              <a:off x="2809167" y="4212686"/>
+              <a:ext cx="4738806" cy="4719490"/>
+            </a:xfrm>
+            <a:custGeom>
+              <a:avLst/>
+              <a:gdLst/>
+              <a:ahLst/>
+              <a:cxnLst>
+                <a:cxn ang="0">
+                  <a:pos x="wd2" y="hd2"/>
+                </a:cxn>
+                <a:cxn ang="5400000">
+                  <a:pos x="wd2" y="hd2"/>
+                </a:cxn>
+                <a:cxn ang="10800000">
+                  <a:pos x="wd2" y="hd2"/>
+                </a:cxn>
+                <a:cxn ang="16200000">
+                  <a:pos x="wd2" y="hd2"/>
+                </a:cxn>
+              </a:cxnLst>
+              <a:rect l="0" t="0" r="r" b="b"/>
+              <a:pathLst>
+                <a:path w="21482" h="21600" fill="norm" stroke="1" extrusionOk="0">
+                  <a:moveTo>
+                    <a:pt x="19126" y="21600"/>
+                  </a:moveTo>
+                  <a:cubicBezTo>
+                    <a:pt x="20616" y="20585"/>
+                    <a:pt x="21420" y="18876"/>
+                    <a:pt x="21479" y="17053"/>
+                  </a:cubicBezTo>
+                  <a:cubicBezTo>
+                    <a:pt x="21600" y="13242"/>
+                    <a:pt x="18777" y="10487"/>
+                    <a:pt x="16301" y="7865"/>
+                  </a:cubicBezTo>
+                  <a:cubicBezTo>
+                    <a:pt x="14535" y="5995"/>
+                    <a:pt x="12802" y="3910"/>
+                    <a:pt x="10477" y="2447"/>
+                  </a:cubicBezTo>
+                  <a:cubicBezTo>
+                    <a:pt x="7373" y="493"/>
+                    <a:pt x="3654" y="8"/>
+                    <a:pt x="0" y="0"/>
+                  </a:cubicBezTo>
+                </a:path>
+              </a:pathLst>
+            </a:custGeom>
+            <a:noFill/>
+            <a:ln w="63500" cap="flat">
+              <a:solidFill>
+                <a:srgbClr val="FF2600"/>
+              </a:solidFill>
+              <a:prstDash val="solid"/>
+              <a:miter lim="400000"/>
+              <a:tailEnd type="triangle" w="med" len="med"/>
+            </a:ln>
+            <a:effectLst/>
+          </p:spPr>
+          <p:txBody>
+            <a:bodyPr wrap="square" lIns="50800" tIns="50800" rIns="50800" bIns="50800" numCol="1" anchor="ctr">
+              <a:noAutofit/>
+            </a:bodyPr>
+            <a:lstStyle/>
+            <a:p>
+              <a:pPr/>
+            </a:p>
+          </p:txBody>
+        </p:sp>
+        <p:sp>
+          <p:nvSpPr>
+            <p:cNvPr id="231" name="Circle"/>
+            <p:cNvSpPr/>
+            <p:nvPr/>
+          </p:nvSpPr>
+          <p:spPr>
+            <a:xfrm rot="19190248">
+              <a:off x="8082812" y="6458802"/>
+              <a:ext cx="242968" cy="243018"/>
+            </a:xfrm>
+            <a:prstGeom prst="ellipse">
+              <a:avLst/>
+            </a:prstGeom>
+            <a:solidFill>
+              <a:srgbClr val="000000"/>
+            </a:solidFill>
+            <a:ln w="12700" cap="flat">
+              <a:noFill/>
               <a:miter lim="400000"/>
             </a:ln>
             <a:effectLst/>
@@ -10143,1134 +11569,21 @@
             </a:bodyPr>
             <a:lstStyle/>
             <a:p>
-              <a:pPr algn="l">
-                <a:lnSpc>
-                  <a:spcPct val="90000"/>
-                </a:lnSpc>
-                <a:spcBef>
-                  <a:spcPts val="4500"/>
-                </a:spcBef>
-                <a:defRPr sz="4800">
+              <a:pPr defTabSz="825500">
+                <a:defRPr sz="3200">
                   <a:solidFill>
-                    <a:srgbClr val="000000"/>
+                    <a:srgbClr val="FFFFFF"/>
                   </a:solidFill>
-                </a:defRPr>
-              </a:pPr>
-            </a:p>
-          </p:txBody>
-        </p:sp>
-        <p:sp>
-          <p:nvSpPr>
-            <p:cNvPr id="205" name="Line"/>
-            <p:cNvSpPr/>
-            <p:nvPr/>
-          </p:nvSpPr>
-          <p:spPr>
-            <a:xfrm flipH="1">
-              <a:off x="1782855" y="4840083"/>
-              <a:ext cx="397899" cy="52321"/>
-            </a:xfrm>
-            <a:prstGeom prst="line">
-              <a:avLst/>
-            </a:prstGeom>
-            <a:noFill/>
-            <a:ln w="63500" cap="flat">
-              <a:solidFill>
-                <a:srgbClr val="0433FF"/>
-              </a:solidFill>
-              <a:prstDash val="solid"/>
-              <a:miter lim="400000"/>
-            </a:ln>
-            <a:effectLst/>
-          </p:spPr>
-          <p:txBody>
-            <a:bodyPr wrap="square" lIns="50800" tIns="50800" rIns="50800" bIns="50800" numCol="1" anchor="ctr">
-              <a:noAutofit/>
-            </a:bodyPr>
-            <a:lstStyle/>
-            <a:p>
-              <a:pPr algn="l">
-                <a:lnSpc>
-                  <a:spcPct val="90000"/>
-                </a:lnSpc>
-                <a:spcBef>
-                  <a:spcPts val="4500"/>
-                </a:spcBef>
-                <a:defRPr sz="4800">
-                  <a:solidFill>
-                    <a:srgbClr val="000000"/>
-                  </a:solidFill>
-                </a:defRPr>
-              </a:pPr>
-            </a:p>
-          </p:txBody>
-        </p:sp>
-        <p:sp>
-          <p:nvSpPr>
-            <p:cNvPr id="206" name="Line"/>
-            <p:cNvSpPr/>
-            <p:nvPr/>
-          </p:nvSpPr>
-          <p:spPr>
-            <a:xfrm flipV="1">
-              <a:off x="2294362" y="5946610"/>
-              <a:ext cx="291051" cy="276413"/>
-            </a:xfrm>
-            <a:prstGeom prst="line">
-              <a:avLst/>
-            </a:prstGeom>
-            <a:noFill/>
-            <a:ln w="63500" cap="flat">
-              <a:solidFill>
-                <a:srgbClr val="0433FF"/>
-              </a:solidFill>
-              <a:prstDash val="solid"/>
-              <a:miter lim="400000"/>
-            </a:ln>
-            <a:effectLst/>
-          </p:spPr>
-          <p:txBody>
-            <a:bodyPr wrap="square" lIns="50800" tIns="50800" rIns="50800" bIns="50800" numCol="1" anchor="ctr">
-              <a:noAutofit/>
-            </a:bodyPr>
-            <a:lstStyle/>
-            <a:p>
-              <a:pPr algn="l">
-                <a:lnSpc>
-                  <a:spcPct val="90000"/>
-                </a:lnSpc>
-                <a:spcBef>
-                  <a:spcPts val="4500"/>
-                </a:spcBef>
-                <a:defRPr sz="4800">
-                  <a:solidFill>
-                    <a:srgbClr val="000000"/>
-                  </a:solidFill>
-                </a:defRPr>
-              </a:pPr>
-            </a:p>
-          </p:txBody>
-        </p:sp>
-        <p:sp>
-          <p:nvSpPr>
-            <p:cNvPr id="207" name="Line"/>
-            <p:cNvSpPr/>
-            <p:nvPr/>
-          </p:nvSpPr>
-          <p:spPr>
-            <a:xfrm flipV="1">
-              <a:off x="3513385" y="6307510"/>
-              <a:ext cx="59238" cy="397071"/>
-            </a:xfrm>
-            <a:prstGeom prst="line">
-              <a:avLst/>
-            </a:prstGeom>
-            <a:noFill/>
-            <a:ln w="63500" cap="flat">
-              <a:solidFill>
-                <a:srgbClr val="0433FF"/>
-              </a:solidFill>
-              <a:prstDash val="solid"/>
-              <a:miter lim="400000"/>
-            </a:ln>
-            <a:effectLst/>
-          </p:spPr>
-          <p:txBody>
-            <a:bodyPr wrap="square" lIns="50800" tIns="50800" rIns="50800" bIns="50800" numCol="1" anchor="ctr">
-              <a:noAutofit/>
-            </a:bodyPr>
-            <a:lstStyle/>
-            <a:p>
-              <a:pPr algn="l">
-                <a:lnSpc>
-                  <a:spcPct val="90000"/>
-                </a:lnSpc>
-                <a:spcBef>
-                  <a:spcPts val="4500"/>
-                </a:spcBef>
-                <a:defRPr sz="4800">
-                  <a:solidFill>
-                    <a:srgbClr val="000000"/>
-                  </a:solidFill>
-                </a:defRPr>
-              </a:pPr>
-            </a:p>
-          </p:txBody>
-        </p:sp>
-        <p:sp>
-          <p:nvSpPr>
-            <p:cNvPr id="208" name="Line"/>
-            <p:cNvSpPr/>
-            <p:nvPr/>
-          </p:nvSpPr>
-          <p:spPr>
-            <a:xfrm flipV="1">
-              <a:off x="4761355" y="6340316"/>
-              <a:ext cx="1" cy="401468"/>
-            </a:xfrm>
-            <a:prstGeom prst="line">
-              <a:avLst/>
-            </a:prstGeom>
-            <a:noFill/>
-            <a:ln w="63500" cap="flat">
-              <a:solidFill>
-                <a:srgbClr val="0433FF"/>
-              </a:solidFill>
-              <a:prstDash val="solid"/>
-              <a:miter lim="400000"/>
-            </a:ln>
-            <a:effectLst/>
-          </p:spPr>
-          <p:txBody>
-            <a:bodyPr wrap="square" lIns="50800" tIns="50800" rIns="50800" bIns="50800" numCol="1" anchor="ctr">
-              <a:noAutofit/>
-            </a:bodyPr>
-            <a:lstStyle/>
-            <a:p>
-              <a:pPr algn="l">
-                <a:lnSpc>
-                  <a:spcPct val="90000"/>
-                </a:lnSpc>
-                <a:spcBef>
-                  <a:spcPts val="4500"/>
-                </a:spcBef>
-                <a:defRPr sz="4800">
-                  <a:solidFill>
-                    <a:srgbClr val="000000"/>
-                  </a:solidFill>
-                </a:defRPr>
-              </a:pPr>
-            </a:p>
-          </p:txBody>
-        </p:sp>
-        <p:sp>
-          <p:nvSpPr>
-            <p:cNvPr id="209" name="Line"/>
-            <p:cNvSpPr/>
-            <p:nvPr/>
-          </p:nvSpPr>
-          <p:spPr>
-            <a:xfrm flipV="1">
-              <a:off x="5904050" y="6305312"/>
-              <a:ext cx="1" cy="401467"/>
-            </a:xfrm>
-            <a:prstGeom prst="line">
-              <a:avLst/>
-            </a:prstGeom>
-            <a:noFill/>
-            <a:ln w="63500" cap="flat">
-              <a:solidFill>
-                <a:srgbClr val="0433FF"/>
-              </a:solidFill>
-              <a:prstDash val="solid"/>
-              <a:miter lim="400000"/>
-            </a:ln>
-            <a:effectLst/>
-          </p:spPr>
-          <p:txBody>
-            <a:bodyPr wrap="square" lIns="50800" tIns="50800" rIns="50800" bIns="50800" numCol="1" anchor="ctr">
-              <a:noAutofit/>
-            </a:bodyPr>
-            <a:lstStyle/>
-            <a:p>
-              <a:pPr algn="l">
-                <a:lnSpc>
-                  <a:spcPct val="90000"/>
-                </a:lnSpc>
-                <a:spcBef>
-                  <a:spcPts val="4500"/>
-                </a:spcBef>
-                <a:defRPr sz="4800">
-                  <a:solidFill>
-                    <a:srgbClr val="000000"/>
-                  </a:solidFill>
-                </a:defRPr>
-              </a:pPr>
-            </a:p>
-          </p:txBody>
-        </p:sp>
-        <p:sp>
-          <p:nvSpPr>
-            <p:cNvPr id="210" name="Line"/>
-            <p:cNvSpPr/>
-            <p:nvPr/>
-          </p:nvSpPr>
-          <p:spPr>
-            <a:xfrm flipV="1">
-              <a:off x="7064428" y="6305312"/>
-              <a:ext cx="1" cy="401467"/>
-            </a:xfrm>
-            <a:prstGeom prst="line">
-              <a:avLst/>
-            </a:prstGeom>
-            <a:noFill/>
-            <a:ln w="63500" cap="flat">
-              <a:solidFill>
-                <a:srgbClr val="0433FF"/>
-              </a:solidFill>
-              <a:prstDash val="solid"/>
-              <a:miter lim="400000"/>
-            </a:ln>
-            <a:effectLst/>
-          </p:spPr>
-          <p:txBody>
-            <a:bodyPr wrap="square" lIns="50800" tIns="50800" rIns="50800" bIns="50800" numCol="1" anchor="ctr">
-              <a:noAutofit/>
-            </a:bodyPr>
-            <a:lstStyle/>
-            <a:p>
-              <a:pPr algn="l">
-                <a:lnSpc>
-                  <a:spcPct val="90000"/>
-                </a:lnSpc>
-                <a:spcBef>
-                  <a:spcPts val="4500"/>
-                </a:spcBef>
-                <a:defRPr sz="4800">
-                  <a:solidFill>
-                    <a:srgbClr val="000000"/>
-                  </a:solidFill>
-                </a:defRPr>
-              </a:pPr>
-            </a:p>
-          </p:txBody>
-        </p:sp>
-        <p:sp>
-          <p:nvSpPr>
-            <p:cNvPr id="211" name="Line"/>
-            <p:cNvSpPr/>
-            <p:nvPr/>
-          </p:nvSpPr>
-          <p:spPr>
-            <a:xfrm flipV="1">
-              <a:off x="8192671" y="6216859"/>
-              <a:ext cx="1" cy="401468"/>
-            </a:xfrm>
-            <a:prstGeom prst="line">
-              <a:avLst/>
-            </a:prstGeom>
-            <a:noFill/>
-            <a:ln w="63500" cap="flat">
-              <a:solidFill>
-                <a:srgbClr val="0433FF"/>
-              </a:solidFill>
-              <a:prstDash val="solid"/>
-              <a:miter lim="400000"/>
-            </a:ln>
-            <a:effectLst/>
-          </p:spPr>
-          <p:txBody>
-            <a:bodyPr wrap="square" lIns="50800" tIns="50800" rIns="50800" bIns="50800" numCol="1" anchor="ctr">
-              <a:noAutofit/>
-            </a:bodyPr>
-            <a:lstStyle/>
-            <a:p>
-              <a:pPr algn="l">
-                <a:lnSpc>
-                  <a:spcPct val="90000"/>
-                </a:lnSpc>
-                <a:spcBef>
-                  <a:spcPts val="4500"/>
-                </a:spcBef>
-                <a:defRPr sz="4800">
-                  <a:solidFill>
-                    <a:srgbClr val="000000"/>
-                  </a:solidFill>
-                </a:defRPr>
-              </a:pPr>
-            </a:p>
-          </p:txBody>
-        </p:sp>
-        <p:sp>
-          <p:nvSpPr>
-            <p:cNvPr id="212" name="Line"/>
-            <p:cNvSpPr/>
-            <p:nvPr/>
-          </p:nvSpPr>
-          <p:spPr>
-            <a:xfrm flipH="1" flipV="1">
-              <a:off x="9258296" y="5935892"/>
-              <a:ext cx="252561" cy="311999"/>
-            </a:xfrm>
-            <a:prstGeom prst="line">
-              <a:avLst/>
-            </a:prstGeom>
-            <a:noFill/>
-            <a:ln w="63500" cap="flat">
-              <a:solidFill>
-                <a:srgbClr val="0433FF"/>
-              </a:solidFill>
-              <a:prstDash val="solid"/>
-              <a:miter lim="400000"/>
-            </a:ln>
-            <a:effectLst/>
-          </p:spPr>
-          <p:txBody>
-            <a:bodyPr wrap="square" lIns="50800" tIns="50800" rIns="50800" bIns="50800" numCol="1" anchor="ctr">
-              <a:noAutofit/>
-            </a:bodyPr>
-            <a:lstStyle/>
-            <a:p>
-              <a:pPr algn="l">
-                <a:lnSpc>
-                  <a:spcPct val="90000"/>
-                </a:lnSpc>
-                <a:spcBef>
-                  <a:spcPts val="4500"/>
-                </a:spcBef>
-                <a:defRPr sz="4800">
-                  <a:solidFill>
-                    <a:srgbClr val="000000"/>
-                  </a:solidFill>
-                </a:defRPr>
-              </a:pPr>
-            </a:p>
-          </p:txBody>
-        </p:sp>
-        <p:sp>
-          <p:nvSpPr>
-            <p:cNvPr id="213" name="Line"/>
-            <p:cNvSpPr/>
-            <p:nvPr/>
-          </p:nvSpPr>
-          <p:spPr>
-            <a:xfrm flipH="1" flipV="1">
-              <a:off x="10059399" y="5082359"/>
-              <a:ext cx="374666" cy="143873"/>
-            </a:xfrm>
-            <a:prstGeom prst="line">
-              <a:avLst/>
-            </a:prstGeom>
-            <a:noFill/>
-            <a:ln w="63500" cap="flat">
-              <a:solidFill>
-                <a:srgbClr val="0433FF"/>
-              </a:solidFill>
-              <a:prstDash val="solid"/>
-              <a:miter lim="400000"/>
-            </a:ln>
-            <a:effectLst/>
-          </p:spPr>
-          <p:txBody>
-            <a:bodyPr wrap="square" lIns="50800" tIns="50800" rIns="50800" bIns="50800" numCol="1" anchor="ctr">
-              <a:noAutofit/>
-            </a:bodyPr>
-            <a:lstStyle/>
-            <a:p>
-              <a:pPr algn="l">
-                <a:lnSpc>
-                  <a:spcPct val="90000"/>
-                </a:lnSpc>
-                <a:spcBef>
-                  <a:spcPts val="4500"/>
-                </a:spcBef>
-                <a:defRPr sz="4800">
-                  <a:solidFill>
-                    <a:srgbClr val="000000"/>
-                  </a:solidFill>
-                </a:defRPr>
-              </a:pPr>
-            </a:p>
-          </p:txBody>
-        </p:sp>
-        <p:sp>
-          <p:nvSpPr>
-            <p:cNvPr id="214" name="Line"/>
-            <p:cNvSpPr/>
-            <p:nvPr/>
-          </p:nvSpPr>
-          <p:spPr>
-            <a:xfrm flipH="1">
-              <a:off x="10274032" y="3846038"/>
-              <a:ext cx="391036" cy="90312"/>
-            </a:xfrm>
-            <a:prstGeom prst="line">
-              <a:avLst/>
-            </a:prstGeom>
-            <a:noFill/>
-            <a:ln w="63500" cap="flat">
-              <a:solidFill>
-                <a:srgbClr val="0433FF"/>
-              </a:solidFill>
-              <a:prstDash val="solid"/>
-              <a:miter lim="400000"/>
-            </a:ln>
-            <a:effectLst/>
-          </p:spPr>
-          <p:txBody>
-            <a:bodyPr wrap="square" lIns="50800" tIns="50800" rIns="50800" bIns="50800" numCol="1" anchor="ctr">
-              <a:noAutofit/>
-            </a:bodyPr>
-            <a:lstStyle/>
-            <a:p>
-              <a:pPr algn="l">
-                <a:lnSpc>
-                  <a:spcPct val="90000"/>
-                </a:lnSpc>
-                <a:spcBef>
-                  <a:spcPts val="4500"/>
-                </a:spcBef>
-                <a:defRPr sz="4800">
-                  <a:solidFill>
-                    <a:srgbClr val="000000"/>
-                  </a:solidFill>
-                </a:defRPr>
-              </a:pPr>
-            </a:p>
-          </p:txBody>
-        </p:sp>
-        <p:sp>
-          <p:nvSpPr>
-            <p:cNvPr id="215" name="Line"/>
-            <p:cNvSpPr/>
-            <p:nvPr/>
-          </p:nvSpPr>
-          <p:spPr>
-            <a:xfrm flipH="1">
-              <a:off x="9762830" y="2609618"/>
-              <a:ext cx="302882" cy="263387"/>
-            </a:xfrm>
-            <a:prstGeom prst="line">
-              <a:avLst/>
-            </a:prstGeom>
-            <a:noFill/>
-            <a:ln w="63500" cap="flat">
-              <a:solidFill>
-                <a:srgbClr val="0433FF"/>
-              </a:solidFill>
-              <a:prstDash val="solid"/>
-              <a:miter lim="400000"/>
-            </a:ln>
-            <a:effectLst/>
-          </p:spPr>
-          <p:txBody>
-            <a:bodyPr wrap="square" lIns="50800" tIns="50800" rIns="50800" bIns="50800" numCol="1" anchor="ctr">
-              <a:noAutofit/>
-            </a:bodyPr>
-            <a:lstStyle/>
-            <a:p>
-              <a:pPr algn="l">
-                <a:lnSpc>
-                  <a:spcPct val="90000"/>
-                </a:lnSpc>
-                <a:spcBef>
-                  <a:spcPts val="4500"/>
-                </a:spcBef>
-                <a:defRPr sz="4800">
-                  <a:solidFill>
-                    <a:srgbClr val="000000"/>
-                  </a:solidFill>
-                </a:defRPr>
-              </a:pPr>
-            </a:p>
-          </p:txBody>
-        </p:sp>
-        <p:sp>
-          <p:nvSpPr>
-            <p:cNvPr id="216" name="Line"/>
-            <p:cNvSpPr/>
-            <p:nvPr/>
-          </p:nvSpPr>
-          <p:spPr>
-            <a:xfrm flipH="1">
-              <a:off x="8811404" y="1854336"/>
-              <a:ext cx="76577" cy="394092"/>
-            </a:xfrm>
-            <a:prstGeom prst="line">
-              <a:avLst/>
-            </a:prstGeom>
-            <a:noFill/>
-            <a:ln w="63500" cap="flat">
-              <a:solidFill>
-                <a:srgbClr val="0433FF"/>
-              </a:solidFill>
-              <a:prstDash val="solid"/>
-              <a:miter lim="400000"/>
-            </a:ln>
-            <a:effectLst/>
-          </p:spPr>
-          <p:txBody>
-            <a:bodyPr wrap="square" lIns="50800" tIns="50800" rIns="50800" bIns="50800" numCol="1" anchor="ctr">
-              <a:noAutofit/>
-            </a:bodyPr>
-            <a:lstStyle/>
-            <a:p>
-              <a:pPr algn="l">
-                <a:lnSpc>
-                  <a:spcPct val="90000"/>
-                </a:lnSpc>
-                <a:spcBef>
-                  <a:spcPts val="4500"/>
-                </a:spcBef>
-                <a:defRPr sz="4800">
-                  <a:solidFill>
-                    <a:srgbClr val="000000"/>
-                  </a:solidFill>
+                  <a:latin typeface="Helvetica Neue Medium"/>
+                  <a:ea typeface="Helvetica Neue Medium"/>
+                  <a:cs typeface="Helvetica Neue Medium"/>
+                  <a:sym typeface="Helvetica Neue Medium"/>
                 </a:defRPr>
               </a:pPr>
             </a:p>
           </p:txBody>
         </p:sp>
       </p:grpSp>
-      <p:sp>
-        <p:nvSpPr>
-          <p:cNvPr id="218" name="Triangle"/>
-          <p:cNvSpPr/>
-          <p:nvPr/>
-        </p:nvSpPr>
-        <p:spPr>
-          <a:xfrm rot="14158077">
-            <a:off x="14996045" y="10522593"/>
-            <a:ext cx="2499702" cy="1249851"/>
-          </a:xfrm>
-          <a:custGeom>
-            <a:avLst/>
-            <a:gdLst/>
-            <a:ahLst/>
-            <a:cxnLst>
-              <a:cxn ang="0">
-                <a:pos x="wd2" y="hd2"/>
-              </a:cxn>
-              <a:cxn ang="5400000">
-                <a:pos x="wd2" y="hd2"/>
-              </a:cxn>
-              <a:cxn ang="10800000">
-                <a:pos x="wd2" y="hd2"/>
-              </a:cxn>
-              <a:cxn ang="16200000">
-                <a:pos x="wd2" y="hd2"/>
-              </a:cxn>
-            </a:cxnLst>
-            <a:rect l="0" t="0" r="r" b="b"/>
-            <a:pathLst>
-              <a:path w="21600" h="21600" fill="norm" stroke="1" extrusionOk="0">
-                <a:moveTo>
-                  <a:pt x="0" y="0"/>
-                </a:moveTo>
-                <a:lnTo>
-                  <a:pt x="10800" y="21600"/>
-                </a:lnTo>
-                <a:lnTo>
-                  <a:pt x="21600" y="0"/>
-                </a:lnTo>
-                <a:lnTo>
-                  <a:pt x="0" y="0"/>
-                </a:lnTo>
-                <a:close/>
-              </a:path>
-            </a:pathLst>
-          </a:custGeom>
-          <a:solidFill>
-            <a:srgbClr val="009051">
-              <a:alpha val="51345"/>
-            </a:srgbClr>
-          </a:solidFill>
-          <a:ln w="12700">
-            <a:miter lim="400000"/>
-          </a:ln>
-        </p:spPr>
-        <p:txBody>
-          <a:bodyPr lIns="50800" tIns="50800" rIns="50800" bIns="50800" anchor="ctr"/>
-          <a:lstStyle/>
-          <a:p>
-            <a:pPr defTabSz="825500">
-              <a:defRPr sz="3200">
-                <a:solidFill>
-                  <a:srgbClr val="FFFFFF"/>
-                </a:solidFill>
-                <a:latin typeface="Helvetica Neue Medium"/>
-                <a:ea typeface="Helvetica Neue Medium"/>
-                <a:cs typeface="Helvetica Neue Medium"/>
-                <a:sym typeface="Helvetica Neue Medium"/>
-              </a:defRPr>
-            </a:pPr>
-          </a:p>
-        </p:txBody>
-      </p:sp>
-      <p:sp>
-        <p:nvSpPr>
-          <p:cNvPr id="219" name="Line"/>
-          <p:cNvSpPr/>
-          <p:nvPr/>
-        </p:nvSpPr>
-        <p:spPr>
-          <a:xfrm>
-            <a:off x="17353410" y="3310412"/>
-            <a:ext cx="4058565" cy="3206391"/>
-          </a:xfrm>
-          <a:prstGeom prst="line">
-            <a:avLst/>
-          </a:prstGeom>
-          <a:ln w="63500">
-            <a:solidFill>
-              <a:srgbClr val="FF2600"/>
-            </a:solidFill>
-            <a:miter lim="400000"/>
-            <a:tailEnd type="triangle"/>
-          </a:ln>
-        </p:spPr>
-        <p:txBody>
-          <a:bodyPr lIns="50800" tIns="50800" rIns="50800" bIns="50800" anchor="ctr"/>
-          <a:lstStyle/>
-          <a:p>
-            <a:pPr/>
-          </a:p>
-        </p:txBody>
-      </p:sp>
-      <p:sp>
-        <p:nvSpPr>
-          <p:cNvPr id="220" name="Line"/>
-          <p:cNvSpPr/>
-          <p:nvPr/>
-        </p:nvSpPr>
-        <p:spPr>
-          <a:xfrm>
-            <a:off x="16699763" y="10780557"/>
-            <a:ext cx="2360686" cy="1855500"/>
-          </a:xfrm>
-          <a:prstGeom prst="line">
-            <a:avLst/>
-          </a:prstGeom>
-          <a:ln w="63500">
-            <a:solidFill>
-              <a:schemeClr val="accent4">
-                <a:hueOff val="-858837"/>
-                <a:lumOff val="-9791"/>
-              </a:schemeClr>
-            </a:solidFill>
-            <a:miter lim="400000"/>
-            <a:tailEnd type="triangle"/>
-          </a:ln>
-        </p:spPr>
-        <p:txBody>
-          <a:bodyPr lIns="50800" tIns="50800" rIns="50800" bIns="50800" anchor="ctr"/>
-          <a:lstStyle/>
-          <a:p>
-            <a:pPr/>
-          </a:p>
-        </p:txBody>
-      </p:sp>
-      <p:sp>
-        <p:nvSpPr>
-          <p:cNvPr id="221" name="Line"/>
-          <p:cNvSpPr/>
-          <p:nvPr/>
-        </p:nvSpPr>
-        <p:spPr>
-          <a:xfrm rot="664785">
-            <a:off x="16806586" y="9536405"/>
-            <a:ext cx="4492337" cy="1927507"/>
-          </a:xfrm>
-          <a:custGeom>
-            <a:avLst/>
-            <a:gdLst/>
-            <a:ahLst/>
-            <a:cxnLst>
-              <a:cxn ang="0">
-                <a:pos x="wd2" y="hd2"/>
-              </a:cxn>
-              <a:cxn ang="5400000">
-                <a:pos x="wd2" y="hd2"/>
-              </a:cxn>
-              <a:cxn ang="10800000">
-                <a:pos x="wd2" y="hd2"/>
-              </a:cxn>
-              <a:cxn ang="16200000">
-                <a:pos x="wd2" y="hd2"/>
-              </a:cxn>
-            </a:cxnLst>
-            <a:rect l="0" t="0" r="r" b="b"/>
-            <a:pathLst>
-              <a:path w="21600" h="20897" fill="norm" stroke="1" extrusionOk="0">
-                <a:moveTo>
-                  <a:pt x="0" y="18787"/>
-                </a:moveTo>
-                <a:cubicBezTo>
-                  <a:pt x="3636" y="21529"/>
-                  <a:pt x="7565" y="21600"/>
-                  <a:pt x="11220" y="18990"/>
-                </a:cubicBezTo>
-                <a:cubicBezTo>
-                  <a:pt x="15621" y="15847"/>
-                  <a:pt x="19330" y="9062"/>
-                  <a:pt x="21600" y="0"/>
-                </a:cubicBezTo>
-              </a:path>
-            </a:pathLst>
-          </a:custGeom>
-          <a:ln w="63500">
-            <a:solidFill>
-              <a:srgbClr val="FF2600"/>
-            </a:solidFill>
-            <a:miter lim="400000"/>
-            <a:tailEnd type="triangle"/>
-          </a:ln>
-        </p:spPr>
-        <p:txBody>
-          <a:bodyPr lIns="50800" tIns="50800" rIns="50800" bIns="50800" anchor="ctr"/>
-          <a:lstStyle/>
-          <a:p>
-            <a:pPr/>
-          </a:p>
-        </p:txBody>
-      </p:sp>
-      <p:sp>
-        <p:nvSpPr>
-          <p:cNvPr id="222" name="Circle"/>
-          <p:cNvSpPr/>
-          <p:nvPr/>
-        </p:nvSpPr>
-        <p:spPr>
-          <a:xfrm>
-            <a:off x="16584550" y="10708765"/>
-            <a:ext cx="239522" cy="239522"/>
-          </a:xfrm>
-          <a:prstGeom prst="ellipse">
-            <a:avLst/>
-          </a:prstGeom>
-          <a:solidFill>
-            <a:srgbClr val="000000"/>
-          </a:solidFill>
-          <a:ln w="12700">
-            <a:miter lim="400000"/>
-          </a:ln>
-        </p:spPr>
-        <p:txBody>
-          <a:bodyPr lIns="50800" tIns="50800" rIns="50800" bIns="50800" anchor="ctr"/>
-          <a:lstStyle/>
-          <a:p>
-            <a:pPr defTabSz="825500">
-              <a:defRPr sz="3200">
-                <a:solidFill>
-                  <a:srgbClr val="FFFFFF"/>
-                </a:solidFill>
-                <a:latin typeface="Helvetica Neue Medium"/>
-                <a:ea typeface="Helvetica Neue Medium"/>
-                <a:cs typeface="Helvetica Neue Medium"/>
-                <a:sym typeface="Helvetica Neue Medium"/>
-              </a:defRPr>
-            </a:pPr>
-          </a:p>
-        </p:txBody>
-      </p:sp>
-      <p:sp>
-        <p:nvSpPr>
-          <p:cNvPr id="223" name="Triangle"/>
-          <p:cNvSpPr/>
-          <p:nvPr/>
-        </p:nvSpPr>
-        <p:spPr>
-          <a:xfrm rot="16183768">
-            <a:off x="14400953" y="8745526"/>
-            <a:ext cx="1988502" cy="1008269"/>
-          </a:xfrm>
-          <a:custGeom>
-            <a:avLst/>
-            <a:gdLst/>
-            <a:ahLst/>
-            <a:cxnLst>
-              <a:cxn ang="0">
-                <a:pos x="wd2" y="hd2"/>
-              </a:cxn>
-              <a:cxn ang="5400000">
-                <a:pos x="wd2" y="hd2"/>
-              </a:cxn>
-              <a:cxn ang="10800000">
-                <a:pos x="wd2" y="hd2"/>
-              </a:cxn>
-              <a:cxn ang="16200000">
-                <a:pos x="wd2" y="hd2"/>
-              </a:cxn>
-            </a:cxnLst>
-            <a:rect l="0" t="0" r="r" b="b"/>
-            <a:pathLst>
-              <a:path w="21600" h="21600" fill="norm" stroke="1" extrusionOk="0">
-                <a:moveTo>
-                  <a:pt x="0" y="0"/>
-                </a:moveTo>
-                <a:lnTo>
-                  <a:pt x="10800" y="21600"/>
-                </a:lnTo>
-                <a:lnTo>
-                  <a:pt x="21600" y="0"/>
-                </a:lnTo>
-                <a:lnTo>
-                  <a:pt x="0" y="0"/>
-                </a:lnTo>
-                <a:close/>
-              </a:path>
-            </a:pathLst>
-          </a:custGeom>
-          <a:solidFill>
-            <a:srgbClr val="009051">
-              <a:alpha val="51345"/>
-            </a:srgbClr>
-          </a:solidFill>
-          <a:ln w="12700">
-            <a:miter lim="400000"/>
-          </a:ln>
-        </p:spPr>
-        <p:txBody>
-          <a:bodyPr lIns="50800" tIns="50800" rIns="50800" bIns="50800" anchor="ctr"/>
-          <a:lstStyle/>
-          <a:p>
-            <a:pPr defTabSz="825500">
-              <a:defRPr sz="3200">
-                <a:solidFill>
-                  <a:srgbClr val="FFFFFF"/>
-                </a:solidFill>
-                <a:latin typeface="Helvetica Neue Medium"/>
-                <a:ea typeface="Helvetica Neue Medium"/>
-                <a:cs typeface="Helvetica Neue Medium"/>
-                <a:sym typeface="Helvetica Neue Medium"/>
-              </a:defRPr>
-            </a:pPr>
-          </a:p>
-        </p:txBody>
-      </p:sp>
-      <p:sp>
-        <p:nvSpPr>
-          <p:cNvPr id="224" name="Line"/>
-          <p:cNvSpPr/>
-          <p:nvPr/>
-        </p:nvSpPr>
-        <p:spPr>
-          <a:xfrm>
-            <a:off x="15877753" y="9256534"/>
-            <a:ext cx="5733881" cy="331615"/>
-          </a:xfrm>
-          <a:prstGeom prst="line">
-            <a:avLst/>
-          </a:prstGeom>
-          <a:ln w="63500">
-            <a:solidFill>
-              <a:srgbClr val="FF2600"/>
-            </a:solidFill>
-            <a:miter lim="400000"/>
-            <a:tailEnd type="triangle"/>
-          </a:ln>
-        </p:spPr>
-        <p:txBody>
-          <a:bodyPr lIns="50800" tIns="50800" rIns="50800" bIns="50800" anchor="ctr"/>
-          <a:lstStyle/>
-          <a:p>
-            <a:pPr/>
-          </a:p>
-        </p:txBody>
-      </p:sp>
-      <p:sp>
-        <p:nvSpPr>
-          <p:cNvPr id="225" name="Line"/>
-          <p:cNvSpPr/>
-          <p:nvPr/>
-        </p:nvSpPr>
-        <p:spPr>
-          <a:xfrm flipH="1" flipV="1">
-            <a:off x="15347345" y="3159299"/>
-            <a:ext cx="506952" cy="6133026"/>
-          </a:xfrm>
-          <a:prstGeom prst="line">
-            <a:avLst/>
-          </a:prstGeom>
-          <a:ln w="63500">
-            <a:solidFill>
-              <a:srgbClr val="FF2600"/>
-            </a:solidFill>
-            <a:miter lim="400000"/>
-            <a:tailEnd type="triangle"/>
-          </a:ln>
-        </p:spPr>
-        <p:txBody>
-          <a:bodyPr lIns="50800" tIns="50800" rIns="50800" bIns="50800" anchor="ctr"/>
-          <a:lstStyle/>
-          <a:p>
-            <a:pPr/>
-          </a:p>
-        </p:txBody>
-      </p:sp>
-      <p:sp>
-        <p:nvSpPr>
-          <p:cNvPr id="226" name="Circle"/>
-          <p:cNvSpPr/>
-          <p:nvPr/>
-        </p:nvSpPr>
-        <p:spPr>
-          <a:xfrm rot="2992306">
-            <a:off x="15707734" y="9126372"/>
-            <a:ext cx="239521" cy="239521"/>
-          </a:xfrm>
-          <a:prstGeom prst="ellipse">
-            <a:avLst/>
-          </a:prstGeom>
-          <a:solidFill>
-            <a:srgbClr val="000000"/>
-          </a:solidFill>
-          <a:ln w="12700">
-            <a:miter lim="400000"/>
-          </a:ln>
-        </p:spPr>
-        <p:txBody>
-          <a:bodyPr lIns="50800" tIns="50800" rIns="50800" bIns="50800" anchor="ctr"/>
-          <a:lstStyle/>
-          <a:p>
-            <a:pPr defTabSz="825500">
-              <a:defRPr sz="3200">
-                <a:solidFill>
-                  <a:srgbClr val="FFFFFF"/>
-                </a:solidFill>
-                <a:latin typeface="Helvetica Neue Medium"/>
-                <a:ea typeface="Helvetica Neue Medium"/>
-                <a:cs typeface="Helvetica Neue Medium"/>
-                <a:sym typeface="Helvetica Neue Medium"/>
-              </a:defRPr>
-            </a:pPr>
-          </a:p>
-        </p:txBody>
-      </p:sp>
-      <p:sp>
-        <p:nvSpPr>
-          <p:cNvPr id="227" name="Triangle"/>
-          <p:cNvSpPr/>
-          <p:nvPr/>
-        </p:nvSpPr>
-        <p:spPr>
-          <a:xfrm rot="20575036">
-            <a:off x="16112230" y="2261532"/>
-            <a:ext cx="2056315" cy="1089425"/>
-          </a:xfrm>
-          <a:custGeom>
-            <a:avLst/>
-            <a:gdLst/>
-            <a:ahLst/>
-            <a:cxnLst>
-              <a:cxn ang="0">
-                <a:pos x="wd2" y="hd2"/>
-              </a:cxn>
-              <a:cxn ang="5400000">
-                <a:pos x="wd2" y="hd2"/>
-              </a:cxn>
-              <a:cxn ang="10800000">
-                <a:pos x="wd2" y="hd2"/>
-              </a:cxn>
-              <a:cxn ang="16200000">
-                <a:pos x="wd2" y="hd2"/>
-              </a:cxn>
-            </a:cxnLst>
-            <a:rect l="0" t="0" r="r" b="b"/>
-            <a:pathLst>
-              <a:path w="21600" h="21600" fill="norm" stroke="1" extrusionOk="0">
-                <a:moveTo>
-                  <a:pt x="0" y="0"/>
-                </a:moveTo>
-                <a:lnTo>
-                  <a:pt x="10800" y="21600"/>
-                </a:lnTo>
-                <a:lnTo>
-                  <a:pt x="21600" y="0"/>
-                </a:lnTo>
-                <a:lnTo>
-                  <a:pt x="0" y="0"/>
-                </a:lnTo>
-                <a:close/>
-              </a:path>
-            </a:pathLst>
-          </a:custGeom>
-          <a:solidFill>
-            <a:srgbClr val="009051">
-              <a:alpha val="51345"/>
-            </a:srgbClr>
-          </a:solidFill>
-          <a:ln w="12700">
-            <a:miter lim="400000"/>
-          </a:ln>
-        </p:spPr>
-        <p:txBody>
-          <a:bodyPr lIns="50800" tIns="50800" rIns="50800" bIns="50800" anchor="ctr"/>
-          <a:lstStyle/>
-          <a:p>
-            <a:pPr defTabSz="825500">
-              <a:defRPr sz="3200">
-                <a:solidFill>
-                  <a:srgbClr val="FFFFFF"/>
-                </a:solidFill>
-                <a:latin typeface="Helvetica Neue Medium"/>
-                <a:ea typeface="Helvetica Neue Medium"/>
-                <a:cs typeface="Helvetica Neue Medium"/>
-                <a:sym typeface="Helvetica Neue Medium"/>
-              </a:defRPr>
-            </a:pPr>
-          </a:p>
-        </p:txBody>
-      </p:sp>
-      <p:sp>
-        <p:nvSpPr>
-          <p:cNvPr id="228" name="Line"/>
-          <p:cNvSpPr/>
-          <p:nvPr/>
-        </p:nvSpPr>
-        <p:spPr>
-          <a:xfrm flipV="1">
-            <a:off x="17353410" y="3295008"/>
-            <a:ext cx="3536016" cy="15404"/>
-          </a:xfrm>
-          <a:prstGeom prst="line">
-            <a:avLst/>
-          </a:prstGeom>
-          <a:ln w="63500">
-            <a:solidFill>
-              <a:srgbClr val="FF2600"/>
-            </a:solidFill>
-            <a:miter lim="400000"/>
-            <a:tailEnd type="triangle"/>
-          </a:ln>
-        </p:spPr>
-        <p:txBody>
-          <a:bodyPr lIns="50800" tIns="50800" rIns="50800" bIns="50800" anchor="ctr"/>
-          <a:lstStyle/>
-          <a:p>
-            <a:pPr/>
-          </a:p>
-        </p:txBody>
-      </p:sp>
-      <p:sp>
-        <p:nvSpPr>
-          <p:cNvPr id="229" name="Circle"/>
-          <p:cNvSpPr/>
-          <p:nvPr/>
-        </p:nvSpPr>
-        <p:spPr>
-          <a:xfrm>
-            <a:off x="17181056" y="3181374"/>
-            <a:ext cx="239522" cy="239522"/>
-          </a:xfrm>
-          <a:prstGeom prst="ellipse">
-            <a:avLst/>
-          </a:prstGeom>
-          <a:solidFill>
-            <a:srgbClr val="000000"/>
-          </a:solidFill>
-          <a:ln w="12700">
-            <a:miter lim="400000"/>
-          </a:ln>
-        </p:spPr>
-        <p:txBody>
-          <a:bodyPr lIns="50800" tIns="50800" rIns="50800" bIns="50800" anchor="ctr"/>
-          <a:lstStyle/>
-          <a:p>
-            <a:pPr defTabSz="825500">
-              <a:defRPr sz="3200">
-                <a:solidFill>
-                  <a:srgbClr val="FFFFFF"/>
-                </a:solidFill>
-                <a:latin typeface="Helvetica Neue Medium"/>
-                <a:ea typeface="Helvetica Neue Medium"/>
-                <a:cs typeface="Helvetica Neue Medium"/>
-                <a:sym typeface="Helvetica Neue Medium"/>
-              </a:defRPr>
-            </a:pPr>
-          </a:p>
-        </p:txBody>
-      </p:sp>
     </p:spTree>
   </p:cSld>
   <p:clrMapOvr>
@@ -11299,7 +11612,7 @@
       </p:grpSpPr>
       <p:sp>
         <p:nvSpPr>
-          <p:cNvPr id="231" name="Line"/>
+          <p:cNvPr id="234" name="Line"/>
           <p:cNvSpPr/>
           <p:nvPr/>
         </p:nvSpPr>
@@ -11330,7 +11643,7 @@
       </p:sp>
       <p:sp>
         <p:nvSpPr>
-          <p:cNvPr id="232" name="Line"/>
+          <p:cNvPr id="235" name="Line"/>
           <p:cNvSpPr/>
           <p:nvPr/>
         </p:nvSpPr>
@@ -11361,7 +11674,7 @@
       </p:sp>
       <p:sp>
         <p:nvSpPr>
-          <p:cNvPr id="233" name="Rectangle"/>
+          <p:cNvPr id="236" name="Rectangle"/>
           <p:cNvSpPr/>
           <p:nvPr/>
         </p:nvSpPr>
@@ -11403,7 +11716,7 @@
       </p:sp>
       <p:sp>
         <p:nvSpPr>
-          <p:cNvPr id="234" name="JRDA L2 gameplay can be difficult for players to play and for officials to officiate because what has the appearance of excellent derby can be illegal.…"/>
+          <p:cNvPr id="237" name="JRDA L2 gameplay can be difficult for players to play and for officials to officiate because what has the appearance of excellent derby can be illegal.…"/>
           <p:cNvSpPr txBox="1"/>
           <p:nvPr/>
         </p:nvSpPr>
@@ -11695,7 +12008,7 @@
       </p:sp>
       <p:sp>
         <p:nvSpPr>
-          <p:cNvPr id="235" name="JRDA L2-Specific Procedures Overvivew"/>
+          <p:cNvPr id="238" name="JRDA L2-Specific Procedures Overvivew"/>
           <p:cNvSpPr txBox="1"/>
           <p:nvPr/>
         </p:nvSpPr>
@@ -11741,7 +12054,7 @@
       </p:sp>
       <p:sp>
         <p:nvSpPr>
-          <p:cNvPr id="236" name="Blocker is legally blocking Jammer, discontinues their block momentarily, and starts a new block by swinging their shoulders, hips, or other legal blocking zones.…"/>
+          <p:cNvPr id="239" name="Blocker is legally blocking Jammer, discontinues their block momentarily, and starts a new block by swinging their shoulders, hips, or other legal blocking zones.…"/>
           <p:cNvSpPr txBox="1"/>
           <p:nvPr/>
         </p:nvSpPr>
@@ -11847,7 +12160,7 @@
       </p:sp>
       <p:sp>
         <p:nvSpPr>
-          <p:cNvPr id="237" name="Scenario #1 - Swinging of the Shoulders or Hips"/>
+          <p:cNvPr id="240" name="Scenario #1 - Swinging of the Shoulders or Hips"/>
           <p:cNvSpPr txBox="1"/>
           <p:nvPr/>
         </p:nvSpPr>
@@ -11893,7 +12206,7 @@
       </p:sp>
       <p:sp>
         <p:nvSpPr>
-          <p:cNvPr id="238" name="Jammer is navigating the pack with an established trajectory and Blocker moves to “catch” Jammer before they exit the pack and front engagement zone.…"/>
+          <p:cNvPr id="241" name="Jammer is navigating the pack with an established trajectory and Blocker moves to “catch” Jammer before they exit the pack and front engagement zone.…"/>
           <p:cNvSpPr txBox="1"/>
           <p:nvPr/>
         </p:nvSpPr>
@@ -12017,7 +12330,7 @@
       </p:sp>
       <p:sp>
         <p:nvSpPr>
-          <p:cNvPr id="239" name="Scenario #3 - Catching"/>
+          <p:cNvPr id="242" name="Scenario #3 - Catching"/>
           <p:cNvSpPr txBox="1"/>
           <p:nvPr/>
         </p:nvSpPr>
@@ -12063,7 +12376,7 @@
       </p:sp>
       <p:sp>
         <p:nvSpPr>
-          <p:cNvPr id="240" name="Jammer is navigating the pack with an established trajectory and Blocker positions themselves in Jammer’s path such that Jammer has no way to avoid making forceful contact to Blocker.…"/>
+          <p:cNvPr id="243" name="Jammer is navigating the pack with an established trajectory and Blocker positions themselves in Jammer’s path such that Jammer has no way to avoid making forceful contact to Blocker.…"/>
           <p:cNvSpPr txBox="1"/>
           <p:nvPr/>
         </p:nvSpPr>
@@ -12151,7 +12464,7 @@
       </p:sp>
       <p:sp>
         <p:nvSpPr>
-          <p:cNvPr id="241" name="Scenario #4 - Initiation Determination B"/>
+          <p:cNvPr id="244" name="Scenario #4 - Initiation Determination B"/>
           <p:cNvSpPr txBox="1"/>
           <p:nvPr/>
         </p:nvSpPr>
@@ -12197,7 +12510,7 @@
       </p:sp>
       <p:sp>
         <p:nvSpPr>
-          <p:cNvPr id="242" name="Jammer initiates forceful contact with Blocker, although due to a size or skill disparity, Blocker absorbs the contact without moving, and Jammer falls to the ground.…"/>
+          <p:cNvPr id="245" name="Jammer initiates forceful contact with Blocker, although due to a size or skill disparity, Blocker absorbs the contact without moving, and Jammer falls to the ground.…"/>
           <p:cNvSpPr txBox="1"/>
           <p:nvPr/>
         </p:nvSpPr>
@@ -12270,7 +12583,7 @@
       </p:sp>
       <p:sp>
         <p:nvSpPr>
-          <p:cNvPr id="243" name="Scenario #2 - Initiation Determination A"/>
+          <p:cNvPr id="246" name="Scenario #2 - Initiation Determination A"/>
           <p:cNvSpPr txBox="1"/>
           <p:nvPr/>
         </p:nvSpPr>
@@ -12316,7 +12629,7 @@
       </p:sp>
       <p:sp>
         <p:nvSpPr>
-          <p:cNvPr id="244" name="In the same scenario, we will allow Jammer to intentionally skate OOB to avoid forceful or potentially dangerous contact that would be unavoidable due to the way Blocker attempts to initiate a block.…"/>
+          <p:cNvPr id="247" name="In the same scenario, we will allow Jammer to intentionally skate OOB to avoid forceful or potentially dangerous contact that would be unavoidable due to the way Blocker attempts to initiate a block.…"/>
           <p:cNvSpPr txBox="1"/>
           <p:nvPr/>
         </p:nvSpPr>
@@ -12404,7 +12717,7 @@
       </p:sp>
       <p:sp>
         <p:nvSpPr>
-          <p:cNvPr id="245" name="Scenario #5 - Skating OOB to Avoid Hitting"/>
+          <p:cNvPr id="248" name="Scenario #5 - Skating OOB to Avoid Hitting"/>
           <p:cNvSpPr txBox="1"/>
           <p:nvPr/>
         </p:nvSpPr>
@@ -12450,7 +12763,7 @@
       </p:sp>
       <p:sp>
         <p:nvSpPr>
-          <p:cNvPr id="246" name="Jammer may approach the pack at any speed, although they are responsible for navigating the pack in a blockable position.…"/>
+          <p:cNvPr id="249" name="Jammer may approach the pack at any speed, although they are responsible for navigating the pack in a blockable position.…"/>
           <p:cNvSpPr txBox="1"/>
           <p:nvPr/>
         </p:nvSpPr>
@@ -12538,7 +12851,7 @@
       </p:sp>
       <p:sp>
         <p:nvSpPr>
-          <p:cNvPr id="247" name="Scenario #6 - Navigating the Pack at High Speed"/>
+          <p:cNvPr id="250" name="Scenario #6 - Navigating the Pack at High Speed"/>
           <p:cNvSpPr txBox="1"/>
           <p:nvPr/>
         </p:nvSpPr>
@@ -12584,7 +12897,7 @@
       </p:sp>
       <p:sp>
         <p:nvSpPr>
-          <p:cNvPr id="248" name="JRDA L2-Specific Procedures"/>
+          <p:cNvPr id="251" name="JRDA L2-Specific Procedures"/>
           <p:cNvSpPr txBox="1"/>
           <p:nvPr/>
         </p:nvSpPr>

</xml_diff>

<commit_message>
Update JRDA L2 instructions Fixes #3
</commit_message>
<xml_diff>
--- a/hr-notes/powerpoint/hr-notes.pptx
+++ b/hr-notes/powerpoint/hr-notes.pptx
@@ -7788,7 +7788,7 @@
         </p:nvSpPr>
         <p:spPr>
           <a:xfrm>
-            <a:off x="12436074" y="12476634"/>
+            <a:off x="12436074" y="9932320"/>
             <a:ext cx="5588001" cy="822923"/>
           </a:xfrm>
           <a:prstGeom prst="rect">
@@ -7892,8 +7892,8 @@
         </p:nvSpPr>
         <p:spPr>
           <a:xfrm>
-            <a:off x="13456375" y="12127877"/>
-            <a:ext cx="3547398" cy="345559"/>
+            <a:off x="13456375" y="9583563"/>
+            <a:ext cx="3547398" cy="345560"/>
           </a:xfrm>
           <a:prstGeom prst="rect">
             <a:avLst/>
@@ -11852,14 +11852,14 @@
       </p:sp>
       <p:sp>
         <p:nvSpPr>
-          <p:cNvPr id="237" name="JRDA L2 gameplay can be difficult for players to play and for officials to officiate because what has the appearance of excellent derby can be illegal.…"/>
+          <p:cNvPr id="237" name="JRDA L2 gameplay can be difficult for players to play and for officials to officiate because contact that looks like normal derby gameplay can sometimes be illegal.…"/>
           <p:cNvSpPr txBox="1"/>
           <p:nvPr/>
         </p:nvSpPr>
         <p:spPr>
           <a:xfrm>
             <a:off x="676536" y="991259"/>
-            <a:ext cx="5588001" cy="5773029"/>
+            <a:ext cx="5588001" cy="5962487"/>
           </a:xfrm>
           <a:prstGeom prst="rect">
             <a:avLst/>
@@ -11897,7 +11897,7 @@
               </a:defRPr>
             </a:pPr>
             <a:r>
-              <a:t>JRDA L2 gameplay can be difficult for players to play and for officials to officiate because what has the appearance of excellent derby can be illegal.</a:t>
+              <a:t>JRDA L2 gameplay can be difficult for players to play and for officials to officiate because contact that looks like normal derby gameplay can sometimes be illegal.</a:t>
             </a:r>
           </a:p>
           <a:p>
@@ -11993,7 +11993,21 @@
               </a:defRPr>
             </a:pPr>
             <a:r>
-              <a:t>Making contact with any swinging of the shoulders, hips, or other legal blocking zones is hitting.</a:t>
+              <a:t>Making contact with any </a:t>
+            </a:r>
+            <a:r>
+              <a:rPr u="sng"/>
+              <a:t>swinging</a:t>
+            </a:r>
+            <a:r>
+              <a:t> of the shoulders, hips, or other </a:t>
+            </a:r>
+            <a:r>
+              <a:rPr u="sng"/>
+              <a:t>legal</a:t>
+            </a:r>
+            <a:r>
+              <a:t> blocking zones is hitting.</a:t>
             </a:r>
           </a:p>
           <a:p>
@@ -12014,7 +12028,7 @@
               </a:defRPr>
             </a:pPr>
             <a:r>
-              <a:t>We penalize for hitting even when players make contact with legal blocking zones to legal target zones.</a:t>
+              <a:t>We penalize for hitting even when players make forceful contact with legal blocking zones to legal target zones.</a:t>
             </a:r>
           </a:p>
           <a:p>
@@ -12035,7 +12049,7 @@
               </a:defRPr>
             </a:pPr>
             <a:r>
-              <a:t>We penalize for forceful contact regardless of game impact.</a:t>
+              <a:t>We penalize for hitting regardless of game impact.</a:t>
             </a:r>
           </a:p>
           <a:p>
@@ -12077,7 +12091,21 @@
               </a:defRPr>
             </a:pPr>
             <a:r>
-              <a:t>It is legal for players to make gentle contact and block using legal blocking zones to legal target zones.</a:t>
+              <a:t>It is </a:t>
+            </a:r>
+            <a:r>
+              <a:rPr u="sng"/>
+              <a:t>legal</a:t>
+            </a:r>
+            <a:r>
+              <a:t> for players to make non-forceful </a:t>
+            </a:r>
+            <a:r>
+              <a:rPr u="sng"/>
+              <a:t>initial</a:t>
+            </a:r>
+            <a:r>
+              <a:t> contact, and then push with force using legal blocking zones on legal target zones.</a:t>
             </a:r>
           </a:p>
           <a:p>
@@ -12098,7 +12126,14 @@
               </a:defRPr>
             </a:pPr>
             <a:r>
-              <a:t>Players may lean or push with force as long as they do not stop their block and initiate a new block with forceful contact.</a:t>
+              <a:t>Players may legally block by leaning on or pushing opposing players forcefully, as long as they do not stop their block and initiate a new block with forceful </a:t>
+            </a:r>
+            <a:r>
+              <a:rPr u="sng"/>
+              <a:t>initial</a:t>
+            </a:r>
+            <a:r>
+              <a:t> contact.</a:t>
             </a:r>
           </a:p>
           <a:p>
@@ -12116,7 +12151,21 @@
               </a:defRPr>
             </a:pPr>
             <a:r>
-              <a:t>In the JRDA L2 ruleset, it is illegal for players to position themselves such they cannot be blocked without an opposing player making forceful contact.</a:t>
+              <a:t>Note that it is </a:t>
+            </a:r>
+            <a:r>
+              <a:rPr u="sng"/>
+              <a:t>illegal</a:t>
+            </a:r>
+            <a:r>
+              <a:t> for players to position themselves in a way that prevents opposing players from having the opportunity to </a:t>
+            </a:r>
+            <a:r>
+              <a:rPr u="sng"/>
+              <a:t>legally</a:t>
+            </a:r>
+            <a:r>
+              <a:t> block them.</a:t>
             </a:r>
           </a:p>
           <a:p>
@@ -12190,13 +12239,13 @@
       </p:sp>
       <p:sp>
         <p:nvSpPr>
-          <p:cNvPr id="239" name="Blocker is legally blocking Jammer, discontinues their block momentarily, and starts a new block by swinging their shoulders, hips, or other legal blocking zones.…"/>
+          <p:cNvPr id="239" name="Blocker is legally blocking Jammer, discontinues their block momentarily, and initiates a new block by swinging their shoulders, hips, or other legal blocking zones.…"/>
           <p:cNvSpPr txBox="1"/>
           <p:nvPr/>
         </p:nvSpPr>
         <p:spPr>
           <a:xfrm>
-            <a:off x="676536" y="7146563"/>
+            <a:off x="676536" y="7337063"/>
             <a:ext cx="5588001" cy="2165169"/>
           </a:xfrm>
           <a:prstGeom prst="rect">
@@ -12235,7 +12284,7 @@
               </a:defRPr>
             </a:pPr>
             <a:r>
-              <a:t>Blocker is legally blocking Jammer, discontinues their block momentarily, and starts a new block by swinging their shoulders, hips, or other legal blocking zones.</a:t>
+              <a:t>Blocker is legally blocking Jammer, discontinues their block momentarily, and initiates a new block by swinging their shoulders, hips, or other legal blocking zones.</a:t>
             </a:r>
           </a:p>
           <a:p>
@@ -12271,7 +12320,7 @@
               </a:defRPr>
             </a:pPr>
             <a:r>
-              <a:t>Blocker may legally block with force as long as they first make gentle or non-forceful initial contact with Jammer.</a:t>
+              <a:t>Blocker must make gentle/non-forceful initial contact with Jammer before leaning or pushing with force.</a:t>
             </a:r>
           </a:p>
           <a:p>
@@ -12289,7 +12338,7 @@
               </a:defRPr>
             </a:pPr>
             <a:r>
-              <a:t>Blocker may legally disengage and reengage their block as long as each new block is non-forceful.</a:t>
+              <a:t>Blocker may legally disengage and re-engage their block as long as the initiation of each new block is non-forceful.</a:t>
             </a:r>
           </a:p>
         </p:txBody>
@@ -12302,7 +12351,7 @@
         </p:nvSpPr>
         <p:spPr>
           <a:xfrm>
-            <a:off x="713475" y="6757442"/>
+            <a:off x="713475" y="6947942"/>
             <a:ext cx="5514123" cy="449272"/>
           </a:xfrm>
           <a:prstGeom prst="rect">
@@ -12423,7 +12472,7 @@
               </a:defRPr>
             </a:pPr>
             <a:r>
-              <a:t>Blocker may legally “catch” Jammer with non-forceful contact and continue to legally block.</a:t>
+              <a:t>Blocker may legally “catch” Jammer with non-forceful contact, and then continue to legally block Jammer.</a:t>
             </a:r>
           </a:p>
           <a:p>
@@ -12441,7 +12490,7 @@
               </a:defRPr>
             </a:pPr>
             <a:r>
-              <a:t>Jammer is allowed to brace for contact although they may not initiate a forceful counter-block.</a:t>
+              <a:t>Jammer is allowed to brace for contact, although they may not initiate a forceful counter-block.</a:t>
             </a:r>
           </a:p>
           <a:p>
@@ -12575,7 +12624,7 @@
               </a:defRPr>
             </a:pPr>
             <a:r>
-              <a:t>In this case, Blocker initiated forceful contact, and we will penalize Blocker for Illegal Contact.</a:t>
+              <a:t>In this case, Blocker is responsible for initiating forceful contact, and we will penalize Blocker for Illegal Contact.</a:t>
             </a:r>
           </a:p>
           <a:p>
@@ -12593,7 +12642,7 @@
               </a:defRPr>
             </a:pPr>
             <a:r>
-              <a:t>“Moving into” this sort of contact is illegal regardless of game impact.</a:t>
+              <a:t>Blocker “moving into” this sort of contact is illegal, regardless of game impact.</a:t>
             </a:r>
           </a:p>
         </p:txBody>
@@ -12646,13 +12695,13 @@
       </p:sp>
       <p:sp>
         <p:nvSpPr>
-          <p:cNvPr id="245" name="Jammer initiates forceful contact with Blocker, although due to a size or skill disparity, Blocker absorbs the contact without moving, and Jammer falls to the ground.…"/>
+          <p:cNvPr id="245" name="Jammer approaches a wall of blockers and initiates forceful contact with Blocker.  Blocker absorbs the contact without moving, and Jammer falls to the ground.…"/>
           <p:cNvSpPr txBox="1"/>
           <p:nvPr/>
         </p:nvSpPr>
         <p:spPr>
           <a:xfrm>
-            <a:off x="676536" y="9706160"/>
+            <a:off x="676536" y="9896660"/>
             <a:ext cx="5588001" cy="1480814"/>
           </a:xfrm>
           <a:prstGeom prst="rect">
@@ -12706,13 +12755,13 @@
           <a:p>
             <a:pPr/>
             <a:r>
-              <a:t>Jammer initiates forceful contact with Blocker, although due to a size or skill disparity, Blocker absorbs the contact without moving, and Jammer falls to the ground.</a:t>
+              <a:t>Jammer approaches a wall of blockers and initiates forceful contact with Blocker.  Blocker absorbs the contact without moving, and Jammer falls to the ground.</a:t>
             </a:r>
           </a:p>
           <a:p>
             <a:pPr lvl="1"/>
             <a:r>
-              <a:t>In this case, we will penalize Jammer for initiating forceful contact regardless of the blocking zone, target zone, or game impact to Blocker.</a:t>
+              <a:t>In this case, we will penalize Jammer for initiating forceful contact, regardless of the blocking zone, target zone, or game impact to Blocker.</a:t>
             </a:r>
           </a:p>
         </p:txBody>
@@ -12725,7 +12774,7 @@
         </p:nvSpPr>
         <p:spPr>
           <a:xfrm>
-            <a:off x="713476" y="9317039"/>
+            <a:off x="713476" y="9507539"/>
             <a:ext cx="5514122" cy="449271"/>
           </a:xfrm>
           <a:prstGeom prst="rect">

</xml_diff>